<commit_message>
Finalize public artifacts and embedding asset
</commit_message>
<xml_diff>
--- a/deliverables/GCN_Robustness_Final_Defense.pptx
+++ b/deliverables/GCN_Robustness_Final_Defense.pptx
@@ -2,26 +2,26 @@
 <file path=ppt/presentation.xml><?xml version="1.0" encoding="utf-8"?>
 <p:presentation xmlns:p="http://schemas.openxmlformats.org/presentationml/2006/main">
   <p:sldMasterIdLst>
-    <p:sldMasterId xmlns:r="http://schemas.openxmlformats.org/officeDocument/2006/relationships" id="2147483648" r:id="Re551d48e47094e91"/>
+    <p:sldMasterId xmlns:r="http://schemas.openxmlformats.org/officeDocument/2006/relationships" id="2147483648" r:id="Rd85d351661db4cfd"/>
   </p:sldMasterIdLst>
   <p:notesMasterIdLst>
-    <p:notesMasterId xmlns:r="http://schemas.openxmlformats.org/officeDocument/2006/relationships" r:id="Ra6d4ae5e5fdd4595"/>
+    <p:notesMasterId xmlns:r="http://schemas.openxmlformats.org/officeDocument/2006/relationships" r:id="Ref9ed744d9cd4fbe"/>
   </p:notesMasterIdLst>
   <p:sldIdLst>
-    <p:sldId xmlns:r="http://schemas.openxmlformats.org/officeDocument/2006/relationships" id="256" r:id="R52ac24ebcfc641ac"/>
-    <p:sldId xmlns:r="http://schemas.openxmlformats.org/officeDocument/2006/relationships" id="257" r:id="R2f814a7394f54603"/>
-    <p:sldId xmlns:r="http://schemas.openxmlformats.org/officeDocument/2006/relationships" id="258" r:id="Rac2fd5839cef41b6"/>
-    <p:sldId xmlns:r="http://schemas.openxmlformats.org/officeDocument/2006/relationships" id="259" r:id="R7f6a96e8f1b34f17"/>
-    <p:sldId xmlns:r="http://schemas.openxmlformats.org/officeDocument/2006/relationships" id="260" r:id="R92c76480ae2c401e"/>
-    <p:sldId xmlns:r="http://schemas.openxmlformats.org/officeDocument/2006/relationships" id="261" r:id="R11ff185264df40c1"/>
-    <p:sldId xmlns:r="http://schemas.openxmlformats.org/officeDocument/2006/relationships" id="262" r:id="R1edd5b7e92ae4bf5"/>
-    <p:sldId xmlns:r="http://schemas.openxmlformats.org/officeDocument/2006/relationships" id="263" r:id="R389471a93ba34160"/>
-    <p:sldId xmlns:r="http://schemas.openxmlformats.org/officeDocument/2006/relationships" id="264" r:id="Rbf06162af332402c"/>
-    <p:sldId xmlns:r="http://schemas.openxmlformats.org/officeDocument/2006/relationships" id="265" r:id="R7f4b3feda0e346c1"/>
-    <p:sldId xmlns:r="http://schemas.openxmlformats.org/officeDocument/2006/relationships" id="266" r:id="Rb1044aad200044db"/>
-    <p:sldId xmlns:r="http://schemas.openxmlformats.org/officeDocument/2006/relationships" id="267" r:id="R2268b1c14b684222"/>
-    <p:sldId xmlns:r="http://schemas.openxmlformats.org/officeDocument/2006/relationships" id="268" r:id="R2c68d341ab7a45c3"/>
-    <p:sldId xmlns:r="http://schemas.openxmlformats.org/officeDocument/2006/relationships" id="269" r:id="R386306a40fe74d51"/>
+    <p:sldId xmlns:r="http://schemas.openxmlformats.org/officeDocument/2006/relationships" id="256" r:id="R29c4cd2380fb402d"/>
+    <p:sldId xmlns:r="http://schemas.openxmlformats.org/officeDocument/2006/relationships" id="257" r:id="Refc594fa94404cca"/>
+    <p:sldId xmlns:r="http://schemas.openxmlformats.org/officeDocument/2006/relationships" id="258" r:id="R3fd3ff5a7e2547b5"/>
+    <p:sldId xmlns:r="http://schemas.openxmlformats.org/officeDocument/2006/relationships" id="259" r:id="R1cb94950ca1e414f"/>
+    <p:sldId xmlns:r="http://schemas.openxmlformats.org/officeDocument/2006/relationships" id="260" r:id="R566babf141c3423a"/>
+    <p:sldId xmlns:r="http://schemas.openxmlformats.org/officeDocument/2006/relationships" id="261" r:id="Rb437bc80bc7a4efb"/>
+    <p:sldId xmlns:r="http://schemas.openxmlformats.org/officeDocument/2006/relationships" id="262" r:id="Rc8d41d246cb34f38"/>
+    <p:sldId xmlns:r="http://schemas.openxmlformats.org/officeDocument/2006/relationships" id="263" r:id="R61bde54aee9549fb"/>
+    <p:sldId xmlns:r="http://schemas.openxmlformats.org/officeDocument/2006/relationships" id="264" r:id="R11ba67ef43c24d1d"/>
+    <p:sldId xmlns:r="http://schemas.openxmlformats.org/officeDocument/2006/relationships" id="265" r:id="R43e04048a075419d"/>
+    <p:sldId xmlns:r="http://schemas.openxmlformats.org/officeDocument/2006/relationships" id="266" r:id="R45f3509411f24d86"/>
+    <p:sldId xmlns:r="http://schemas.openxmlformats.org/officeDocument/2006/relationships" id="267" r:id="Rba4468648fb94c87"/>
+    <p:sldId xmlns:r="http://schemas.openxmlformats.org/officeDocument/2006/relationships" id="268" r:id="R0f782963d7d8487a"/>
+    <p:sldId xmlns:r="http://schemas.openxmlformats.org/officeDocument/2006/relationships" id="269" r:id="R71996256e0e74bf7"/>
   </p:sldIdLst>
   <p:sldSz cx="9144000" cy="5143500"/>
   <p:notesSz cx="6858000" cy="9144000"/>
@@ -1472,7 +1472,7 @@
   </p:cSld>
   <p:clrMap bg1="lt1" tx1="dk1" bg2="lt2" tx2="dk2" accent1="accent1" accent2="accent2" accent3="accent3" accent4="accent4" accent5="accent5" accent6="accent6" hlink="hlink" folHlink="folHlink"/>
   <p:sldLayoutIdLst>
-    <p:sldLayoutId xmlns:r="http://schemas.openxmlformats.org/officeDocument/2006/relationships" id="2147483649" r:id="R146f0d6f22674c78"/>
+    <p:sldLayoutId xmlns:r="http://schemas.openxmlformats.org/officeDocument/2006/relationships" id="2147483649" r:id="R04893e969d4a49b6"/>
   </p:sldLayoutIdLst>
   <p:txStyles>
     <p:titleStyle>
@@ -3724,7 +3724,7 @@
           <p:cNvPr id="1" name="">
             <a:extLst xmlns:a="http://schemas.openxmlformats.org/drawingml/2006/main">
               <a:ext uri="{FF2B5EF4-FFF2-40B4-BE49-F238E27FC236}">
-                <a16:creationId xmlns:a16="http://schemas.microsoft.com/office/drawing/2014/main" id="{5DB8DA55-5A77-424D-8F2E-1A47161332B5}"/>
+                <a16:creationId xmlns:a16="http://schemas.microsoft.com/office/drawing/2014/main" id="{3AC2DDD6-DB3A-4A64-BBBD-EDB9993C0C33}"/>
               </a:ext>
             </a:extLst>
           </p:cNvPr>
@@ -3755,7 +3755,7 @@
           <p:cNvPr id="2" name="">
             <a:extLst xmlns:a="http://schemas.openxmlformats.org/drawingml/2006/main">
               <a:ext uri="{FF2B5EF4-FFF2-40B4-BE49-F238E27FC236}">
-                <a16:creationId xmlns:a16="http://schemas.microsoft.com/office/drawing/2014/main" id="{7958EB28-1448-4008-BC3D-536BD1246C80}"/>
+                <a16:creationId xmlns:a16="http://schemas.microsoft.com/office/drawing/2014/main" id="{029852C7-BF53-4154-A87D-3331330CC92A}"/>
               </a:ext>
             </a:extLst>
           </p:cNvPr>
@@ -3805,7 +3805,7 @@
           <p:cNvPr id="3" name="">
             <a:extLst xmlns:a="http://schemas.openxmlformats.org/drawingml/2006/main">
               <a:ext uri="{FF2B5EF4-FFF2-40B4-BE49-F238E27FC236}">
-                <a16:creationId xmlns:a16="http://schemas.microsoft.com/office/drawing/2014/main" id="{DD0E662A-1F7B-49C8-BF18-0552447227E5}"/>
+                <a16:creationId xmlns:a16="http://schemas.microsoft.com/office/drawing/2014/main" id="{BA4814F7-A14F-4E7C-B456-6F5E37FF231F}"/>
               </a:ext>
             </a:extLst>
           </p:cNvPr>
@@ -3855,7 +3855,7 @@
           <p:cNvPr id="4" name="">
             <a:extLst xmlns:a="http://schemas.openxmlformats.org/drawingml/2006/main">
               <a:ext uri="{FF2B5EF4-FFF2-40B4-BE49-F238E27FC236}">
-                <a16:creationId xmlns:a16="http://schemas.microsoft.com/office/drawing/2014/main" id="{78BC50E7-22E6-4348-9F91-CD941AD1A488}"/>
+                <a16:creationId xmlns:a16="http://schemas.microsoft.com/office/drawing/2014/main" id="{E8D8DB18-3AA7-4A01-9F66-EAB72676D3A3}"/>
               </a:ext>
             </a:extLst>
           </p:cNvPr>
@@ -3905,7 +3905,7 @@
           <p:cNvPr id="5" name="">
             <a:extLst xmlns:a="http://schemas.openxmlformats.org/drawingml/2006/main">
               <a:ext uri="{FF2B5EF4-FFF2-40B4-BE49-F238E27FC236}">
-                <a16:creationId xmlns:a16="http://schemas.microsoft.com/office/drawing/2014/main" id="{0FD2BFD8-BBFD-4C68-B39A-A4ABC2740768}"/>
+                <a16:creationId xmlns:a16="http://schemas.microsoft.com/office/drawing/2014/main" id="{BA357B36-7EC2-47C3-980E-E334CCD82085}"/>
               </a:ext>
             </a:extLst>
           </p:cNvPr>
@@ -3940,7 +3940,7 @@
           <p:cNvPr id="6" name="">
             <a:extLst xmlns:a="http://schemas.openxmlformats.org/drawingml/2006/main">
               <a:ext uri="{FF2B5EF4-FFF2-40B4-BE49-F238E27FC236}">
-                <a16:creationId xmlns:a16="http://schemas.microsoft.com/office/drawing/2014/main" id="{BB2C5DB0-146C-4714-A660-BD640111F7B5}"/>
+                <a16:creationId xmlns:a16="http://schemas.microsoft.com/office/drawing/2014/main" id="{3774F66E-0305-4560-B966-A5C733636062}"/>
               </a:ext>
             </a:extLst>
           </p:cNvPr>
@@ -3990,7 +3990,7 @@
           <p:cNvPr id="7" name="">
             <a:extLst xmlns:a="http://schemas.openxmlformats.org/drawingml/2006/main">
               <a:ext uri="{FF2B5EF4-FFF2-40B4-BE49-F238E27FC236}">
-                <a16:creationId xmlns:a16="http://schemas.microsoft.com/office/drawing/2014/main" id="{1D0A6B1C-973D-4010-941E-9951EB69B018}"/>
+                <a16:creationId xmlns:a16="http://schemas.microsoft.com/office/drawing/2014/main" id="{B44D55DB-39A8-4866-8607-55DB8429E7ED}"/>
               </a:ext>
             </a:extLst>
           </p:cNvPr>
@@ -4040,7 +4040,7 @@
           <p:cNvPr id="8" name="">
             <a:extLst xmlns:a="http://schemas.openxmlformats.org/drawingml/2006/main">
               <a:ext uri="{FF2B5EF4-FFF2-40B4-BE49-F238E27FC236}">
-                <a16:creationId xmlns:a16="http://schemas.microsoft.com/office/drawing/2014/main" id="{B4B0F8B8-9FF7-4AE9-9454-B8BACF58EB38}"/>
+                <a16:creationId xmlns:a16="http://schemas.microsoft.com/office/drawing/2014/main" id="{3459784D-E3D9-4B84-BD3B-E5C684C2AE0E}"/>
               </a:ext>
             </a:extLst>
           </p:cNvPr>
@@ -4075,7 +4075,7 @@
           <p:cNvPr id="9" name="">
             <a:extLst xmlns:a="http://schemas.openxmlformats.org/drawingml/2006/main">
               <a:ext uri="{FF2B5EF4-FFF2-40B4-BE49-F238E27FC236}">
-                <a16:creationId xmlns:a16="http://schemas.microsoft.com/office/drawing/2014/main" id="{F47452E2-11BF-46EB-9012-11C63E13D238}"/>
+                <a16:creationId xmlns:a16="http://schemas.microsoft.com/office/drawing/2014/main" id="{8F8A6F7C-7CC7-4C25-8654-DDAA65C2CDE3}"/>
               </a:ext>
             </a:extLst>
           </p:cNvPr>
@@ -4125,7 +4125,7 @@
           <p:cNvPr id="10" name="">
             <a:extLst xmlns:a="http://schemas.openxmlformats.org/drawingml/2006/main">
               <a:ext uri="{FF2B5EF4-FFF2-40B4-BE49-F238E27FC236}">
-                <a16:creationId xmlns:a16="http://schemas.microsoft.com/office/drawing/2014/main" id="{73D8353D-2A51-46CC-B5C3-FAAA5CA9D34A}"/>
+                <a16:creationId xmlns:a16="http://schemas.microsoft.com/office/drawing/2014/main" id="{5133CC1D-A59E-43BC-ABAA-2F67725D1F7A}"/>
               </a:ext>
             </a:extLst>
           </p:cNvPr>
@@ -4175,7 +4175,7 @@
           <p:cNvPr id="11" name="">
             <a:extLst xmlns:a="http://schemas.openxmlformats.org/drawingml/2006/main">
               <a:ext uri="{FF2B5EF4-FFF2-40B4-BE49-F238E27FC236}">
-                <a16:creationId xmlns:a16="http://schemas.microsoft.com/office/drawing/2014/main" id="{2405FEA3-025D-4017-B9F7-E0693C5A2FCB}"/>
+                <a16:creationId xmlns:a16="http://schemas.microsoft.com/office/drawing/2014/main" id="{766DB966-FAC1-4EB4-8B2F-0AC44762D765}"/>
               </a:ext>
             </a:extLst>
           </p:cNvPr>
@@ -4210,7 +4210,7 @@
           <p:cNvPr id="12" name="">
             <a:extLst xmlns:a="http://schemas.openxmlformats.org/drawingml/2006/main">
               <a:ext uri="{FF2B5EF4-FFF2-40B4-BE49-F238E27FC236}">
-                <a16:creationId xmlns:a16="http://schemas.microsoft.com/office/drawing/2014/main" id="{481457DC-1FF4-4FBD-B580-5E2C70B26D76}"/>
+                <a16:creationId xmlns:a16="http://schemas.microsoft.com/office/drawing/2014/main" id="{8C979FEF-53C8-46CA-8EEA-58BA59FE6F60}"/>
               </a:ext>
             </a:extLst>
           </p:cNvPr>
@@ -4260,7 +4260,7 @@
           <p:cNvPr id="13" name="">
             <a:extLst xmlns:a="http://schemas.openxmlformats.org/drawingml/2006/main">
               <a:ext uri="{FF2B5EF4-FFF2-40B4-BE49-F238E27FC236}">
-                <a16:creationId xmlns:a16="http://schemas.microsoft.com/office/drawing/2014/main" id="{76157475-C77B-4EE9-BB8B-0512C25C423A}"/>
+                <a16:creationId xmlns:a16="http://schemas.microsoft.com/office/drawing/2014/main" id="{DAB36ADF-58DD-41D6-9383-667B18BD123E}"/>
               </a:ext>
             </a:extLst>
           </p:cNvPr>
@@ -4314,7 +4314,7 @@
           <p:nvPr/>
         </p:nvPicPr>
         <p:blipFill>
-          <a:blip xmlns:r="http://schemas.openxmlformats.org/officeDocument/2006/relationships" xmlns:a="http://schemas.openxmlformats.org/drawingml/2006/main" r:embed="Rf53ae91f63664821"/>
+          <a:blip xmlns:r="http://schemas.openxmlformats.org/officeDocument/2006/relationships" xmlns:a="http://schemas.openxmlformats.org/drawingml/2006/main" r:embed="R13fa115edfd74a67"/>
           <a:stretch xmlns:a="http://schemas.openxmlformats.org/drawingml/2006/main"/>
         </p:blipFill>
         <p:spPr>
@@ -4332,7 +4332,7 @@
           <p:cNvPr id="15" name="">
             <a:extLst xmlns:a="http://schemas.openxmlformats.org/drawingml/2006/main">
               <a:ext uri="{FF2B5EF4-FFF2-40B4-BE49-F238E27FC236}">
-                <a16:creationId xmlns:a16="http://schemas.microsoft.com/office/drawing/2014/main" id="{7BC0534E-503F-4E43-9433-2AF935BBEB3A}"/>
+                <a16:creationId xmlns:a16="http://schemas.microsoft.com/office/drawing/2014/main" id="{8DA2C0F6-AD7A-40BF-ADB1-024228959F7A}"/>
               </a:ext>
             </a:extLst>
           </p:cNvPr>
@@ -4380,7 +4380,7 @@
     </p:spTree>
     <p:extLst>
       <p:ext uri="{BB962C8B-B14F-4D97-AF65-F5344CB8AC3E}">
-        <p14:creationId xmlns:p14="http://schemas.microsoft.com/office/powerpoint/2010/main" val="1354695295"/>
+        <p14:creationId xmlns:p14="http://schemas.microsoft.com/office/powerpoint/2010/main" val="1738349566"/>
       </p:ext>
     </p:extLst>
   </p:cSld>
@@ -4411,7 +4411,7 @@
           <p:cNvPr id="1" name="">
             <a:extLst xmlns:a="http://schemas.openxmlformats.org/drawingml/2006/main">
               <a:ext uri="{FF2B5EF4-FFF2-40B4-BE49-F238E27FC236}">
-                <a16:creationId xmlns:a16="http://schemas.microsoft.com/office/drawing/2014/main" id="{0C556BF2-8594-4F8B-A3A2-A1451CBC95FA}"/>
+                <a16:creationId xmlns:a16="http://schemas.microsoft.com/office/drawing/2014/main" id="{EDD8694F-6E2F-4FF2-A215-7C34B8A7C94F}"/>
               </a:ext>
             </a:extLst>
           </p:cNvPr>
@@ -4442,7 +4442,7 @@
           <p:cNvPr id="2" name="">
             <a:extLst xmlns:a="http://schemas.openxmlformats.org/drawingml/2006/main">
               <a:ext uri="{FF2B5EF4-FFF2-40B4-BE49-F238E27FC236}">
-                <a16:creationId xmlns:a16="http://schemas.microsoft.com/office/drawing/2014/main" id="{F17A39C7-4428-4B95-97F4-2F3F92781C68}"/>
+                <a16:creationId xmlns:a16="http://schemas.microsoft.com/office/drawing/2014/main" id="{63FE5A64-2681-4D1C-9738-6F5E1A600671}"/>
               </a:ext>
             </a:extLst>
           </p:cNvPr>
@@ -4492,7 +4492,7 @@
           <p:cNvPr id="3" name="">
             <a:extLst xmlns:a="http://schemas.openxmlformats.org/drawingml/2006/main">
               <a:ext uri="{FF2B5EF4-FFF2-40B4-BE49-F238E27FC236}">
-                <a16:creationId xmlns:a16="http://schemas.microsoft.com/office/drawing/2014/main" id="{E4DBCB80-2AA4-468E-BE8F-1C8BCDFBF862}"/>
+                <a16:creationId xmlns:a16="http://schemas.microsoft.com/office/drawing/2014/main" id="{834E6A23-D292-4C0E-B68C-C7F7D9F8CA41}"/>
               </a:ext>
             </a:extLst>
           </p:cNvPr>
@@ -4532,7 +4532,7 @@
                   <a:srgbClr val="F5F7FB"/>
                 </a:solidFill>
               </a:rPr>
-              <a:t>Robustesse au feature masking</a:t>
+              <a:t>Robustesse au masquage d'attributs</a:t>
             </a:r>
           </a:p>
         </p:txBody>
@@ -4549,14 +4549,14 @@
         </p:xfrm>
         <a:graphic xmlns:a="http://schemas.openxmlformats.org/drawingml/2006/main">
           <a:graphicData uri="http://schemas.openxmlformats.org/drawingml/2006/chart">
-            <c:chart xmlns:r="http://schemas.openxmlformats.org/officeDocument/2006/relationships" xmlns:c="http://schemas.openxmlformats.org/drawingml/2006/chart" r:id="Ra4f49aeaae414b88"/>
+            <c:chart xmlns:r="http://schemas.openxmlformats.org/officeDocument/2006/relationships" xmlns:c="http://schemas.openxmlformats.org/drawingml/2006/chart" r:id="Rc6c493edb6f9497e"/>
           </a:graphicData>
         </a:graphic>
       </p:graphicFrame>
     </p:spTree>
     <p:extLst>
       <p:ext uri="{BB962C8B-B14F-4D97-AF65-F5344CB8AC3E}">
-        <p14:creationId xmlns:p14="http://schemas.microsoft.com/office/powerpoint/2010/main" val="141236841"/>
+        <p14:creationId xmlns:p14="http://schemas.microsoft.com/office/powerpoint/2010/main" val="1312297032"/>
       </p:ext>
     </p:extLst>
   </p:cSld>
@@ -4587,7 +4587,7 @@
           <p:cNvPr id="1" name="">
             <a:extLst xmlns:a="http://schemas.openxmlformats.org/drawingml/2006/main">
               <a:ext uri="{FF2B5EF4-FFF2-40B4-BE49-F238E27FC236}">
-                <a16:creationId xmlns:a16="http://schemas.microsoft.com/office/drawing/2014/main" id="{DAFAAA0A-1E0E-4E56-9D69-2FDA6A93D270}"/>
+                <a16:creationId xmlns:a16="http://schemas.microsoft.com/office/drawing/2014/main" id="{02A8DF82-08B9-4152-9B16-35185419B8B3}"/>
               </a:ext>
             </a:extLst>
           </p:cNvPr>
@@ -4618,7 +4618,7 @@
           <p:cNvPr id="2" name="">
             <a:extLst xmlns:a="http://schemas.openxmlformats.org/drawingml/2006/main">
               <a:ext uri="{FF2B5EF4-FFF2-40B4-BE49-F238E27FC236}">
-                <a16:creationId xmlns:a16="http://schemas.microsoft.com/office/drawing/2014/main" id="{A38F9583-6C11-4325-A9AA-5F6F062D71B0}"/>
+                <a16:creationId xmlns:a16="http://schemas.microsoft.com/office/drawing/2014/main" id="{5A666FDD-639B-4A81-BB09-134E73732328}"/>
               </a:ext>
             </a:extLst>
           </p:cNvPr>
@@ -4668,7 +4668,7 @@
           <p:cNvPr id="3" name="">
             <a:extLst xmlns:a="http://schemas.openxmlformats.org/drawingml/2006/main">
               <a:ext uri="{FF2B5EF4-FFF2-40B4-BE49-F238E27FC236}">
-                <a16:creationId xmlns:a16="http://schemas.microsoft.com/office/drawing/2014/main" id="{DAD4DD1B-D929-4593-9109-9A68A828E10B}"/>
+                <a16:creationId xmlns:a16="http://schemas.microsoft.com/office/drawing/2014/main" id="{7517A541-9ED8-4DEA-9221-B941A5BDF085}"/>
               </a:ext>
             </a:extLst>
           </p:cNvPr>
@@ -4725,7 +4725,7 @@
         </p:xfrm>
         <a:graphic xmlns:a="http://schemas.openxmlformats.org/drawingml/2006/main">
           <a:graphicData uri="http://schemas.openxmlformats.org/drawingml/2006/chart">
-            <c:chart xmlns:r="http://schemas.openxmlformats.org/officeDocument/2006/relationships" xmlns:c="http://schemas.openxmlformats.org/drawingml/2006/chart" r:id="R6ea2ea4aa2144562"/>
+            <c:chart xmlns:r="http://schemas.openxmlformats.org/officeDocument/2006/relationships" xmlns:c="http://schemas.openxmlformats.org/drawingml/2006/chart" r:id="R945b83eba38b4b6b"/>
           </a:graphicData>
         </a:graphic>
       </p:graphicFrame>
@@ -4741,14 +4741,14 @@
         </p:xfrm>
         <a:graphic xmlns:a="http://schemas.openxmlformats.org/drawingml/2006/main">
           <a:graphicData uri="http://schemas.openxmlformats.org/drawingml/2006/chart">
-            <c:chart xmlns:r="http://schemas.openxmlformats.org/officeDocument/2006/relationships" xmlns:c="http://schemas.openxmlformats.org/drawingml/2006/chart" r:id="R4f18333204c64d34"/>
+            <c:chart xmlns:r="http://schemas.openxmlformats.org/officeDocument/2006/relationships" xmlns:c="http://schemas.openxmlformats.org/drawingml/2006/chart" r:id="R0d7c330362f540b5"/>
           </a:graphicData>
         </a:graphic>
       </p:graphicFrame>
     </p:spTree>
     <p:extLst>
       <p:ext uri="{BB962C8B-B14F-4D97-AF65-F5344CB8AC3E}">
-        <p14:creationId xmlns:p14="http://schemas.microsoft.com/office/powerpoint/2010/main" val="1047978497"/>
+        <p14:creationId xmlns:p14="http://schemas.microsoft.com/office/powerpoint/2010/main" val="493624362"/>
       </p:ext>
     </p:extLst>
   </p:cSld>
@@ -4779,7 +4779,7 @@
           <p:cNvPr id="1" name="">
             <a:extLst xmlns:a="http://schemas.openxmlformats.org/drawingml/2006/main">
               <a:ext uri="{FF2B5EF4-FFF2-40B4-BE49-F238E27FC236}">
-                <a16:creationId xmlns:a16="http://schemas.microsoft.com/office/drawing/2014/main" id="{6C76B80D-860B-4F1E-8BC6-C058437C4C81}"/>
+                <a16:creationId xmlns:a16="http://schemas.microsoft.com/office/drawing/2014/main" id="{5223E88E-A69B-4032-834C-AFD0136EC522}"/>
               </a:ext>
             </a:extLst>
           </p:cNvPr>
@@ -4810,7 +4810,7 @@
           <p:cNvPr id="2" name="">
             <a:extLst xmlns:a="http://schemas.openxmlformats.org/drawingml/2006/main">
               <a:ext uri="{FF2B5EF4-FFF2-40B4-BE49-F238E27FC236}">
-                <a16:creationId xmlns:a16="http://schemas.microsoft.com/office/drawing/2014/main" id="{D48018E5-5F1B-45FF-AD65-FB161404AFEB}"/>
+                <a16:creationId xmlns:a16="http://schemas.microsoft.com/office/drawing/2014/main" id="{D3397BEF-56BF-478B-856F-A78CA562DE19}"/>
               </a:ext>
             </a:extLst>
           </p:cNvPr>
@@ -4860,7 +4860,7 @@
           <p:cNvPr id="3" name="">
             <a:extLst xmlns:a="http://schemas.openxmlformats.org/drawingml/2006/main">
               <a:ext uri="{FF2B5EF4-FFF2-40B4-BE49-F238E27FC236}">
-                <a16:creationId xmlns:a16="http://schemas.microsoft.com/office/drawing/2014/main" id="{16741627-5FB6-4383-9ECC-38F04B72061F}"/>
+                <a16:creationId xmlns:a16="http://schemas.microsoft.com/office/drawing/2014/main" id="{9E51C00D-434A-449F-BFE3-CC07F2820B93}"/>
               </a:ext>
             </a:extLst>
           </p:cNvPr>
@@ -4910,7 +4910,7 @@
           <p:cNvPr id="4" name="">
             <a:extLst xmlns:a="http://schemas.openxmlformats.org/drawingml/2006/main">
               <a:ext uri="{FF2B5EF4-FFF2-40B4-BE49-F238E27FC236}">
-                <a16:creationId xmlns:a16="http://schemas.microsoft.com/office/drawing/2014/main" id="{E76AA0EF-27AF-43C7-8308-88E9D9DADD46}"/>
+                <a16:creationId xmlns:a16="http://schemas.microsoft.com/office/drawing/2014/main" id="{75445E9F-FF44-475B-838A-B563E3E34F40}"/>
               </a:ext>
             </a:extLst>
           </p:cNvPr>
@@ -4945,7 +4945,7 @@
           <p:cNvPr id="5" name="">
             <a:extLst xmlns:a="http://schemas.openxmlformats.org/drawingml/2006/main">
               <a:ext uri="{FF2B5EF4-FFF2-40B4-BE49-F238E27FC236}">
-                <a16:creationId xmlns:a16="http://schemas.microsoft.com/office/drawing/2014/main" id="{2D28DA0D-FC96-4429-8CDB-E2F9E71FBF7A}"/>
+                <a16:creationId xmlns:a16="http://schemas.microsoft.com/office/drawing/2014/main" id="{BDDF9CD7-A787-4322-A326-73E09C730EAC}"/>
               </a:ext>
             </a:extLst>
           </p:cNvPr>
@@ -4995,7 +4995,7 @@
           <p:cNvPr id="6" name="">
             <a:extLst xmlns:a="http://schemas.openxmlformats.org/drawingml/2006/main">
               <a:ext uri="{FF2B5EF4-FFF2-40B4-BE49-F238E27FC236}">
-                <a16:creationId xmlns:a16="http://schemas.microsoft.com/office/drawing/2014/main" id="{1528F123-252D-4A4D-810C-9C1B810724D8}"/>
+                <a16:creationId xmlns:a16="http://schemas.microsoft.com/office/drawing/2014/main" id="{8E26FF4E-2EDB-4F7C-A171-E5840119D7DA}"/>
               </a:ext>
             </a:extLst>
           </p:cNvPr>
@@ -5045,7 +5045,7 @@
           <p:cNvPr id="7" name="">
             <a:extLst xmlns:a="http://schemas.openxmlformats.org/drawingml/2006/main">
               <a:ext uri="{FF2B5EF4-FFF2-40B4-BE49-F238E27FC236}">
-                <a16:creationId xmlns:a16="http://schemas.microsoft.com/office/drawing/2014/main" id="{2AFEAD22-295B-4D2C-9722-8E32D34DBE05}"/>
+                <a16:creationId xmlns:a16="http://schemas.microsoft.com/office/drawing/2014/main" id="{031E27FF-3565-425B-B94A-28F5E606F696}"/>
               </a:ext>
             </a:extLst>
           </p:cNvPr>
@@ -5080,7 +5080,7 @@
           <p:cNvPr id="8" name="">
             <a:extLst xmlns:a="http://schemas.openxmlformats.org/drawingml/2006/main">
               <a:ext uri="{FF2B5EF4-FFF2-40B4-BE49-F238E27FC236}">
-                <a16:creationId xmlns:a16="http://schemas.microsoft.com/office/drawing/2014/main" id="{C30EF612-E6B3-46F5-A5D2-0EF3D5CA85CF}"/>
+                <a16:creationId xmlns:a16="http://schemas.microsoft.com/office/drawing/2014/main" id="{102C3D35-F51F-47D6-B952-6710D3CBD03C}"/>
               </a:ext>
             </a:extLst>
           </p:cNvPr>
@@ -5130,7 +5130,7 @@
           <p:cNvPr id="9" name="">
             <a:extLst xmlns:a="http://schemas.openxmlformats.org/drawingml/2006/main">
               <a:ext uri="{FF2B5EF4-FFF2-40B4-BE49-F238E27FC236}">
-                <a16:creationId xmlns:a16="http://schemas.microsoft.com/office/drawing/2014/main" id="{96C7DC0C-3F0F-45DE-A016-1C0FC2DB214E}"/>
+                <a16:creationId xmlns:a16="http://schemas.microsoft.com/office/drawing/2014/main" id="{1046FFB0-5C2D-4965-A67C-AE37CF7B76F5}"/>
               </a:ext>
             </a:extLst>
           </p:cNvPr>
@@ -5180,7 +5180,7 @@
           <p:cNvPr id="10" name="">
             <a:extLst xmlns:a="http://schemas.openxmlformats.org/drawingml/2006/main">
               <a:ext uri="{FF2B5EF4-FFF2-40B4-BE49-F238E27FC236}">
-                <a16:creationId xmlns:a16="http://schemas.microsoft.com/office/drawing/2014/main" id="{AC0DD41D-BE86-4A2A-9207-B60361F5E2B4}"/>
+                <a16:creationId xmlns:a16="http://schemas.microsoft.com/office/drawing/2014/main" id="{01D2B2E0-813A-43CF-B9A2-E82622DC74FB}"/>
               </a:ext>
             </a:extLst>
           </p:cNvPr>
@@ -5215,7 +5215,7 @@
           <p:cNvPr id="11" name="">
             <a:extLst xmlns:a="http://schemas.openxmlformats.org/drawingml/2006/main">
               <a:ext uri="{FF2B5EF4-FFF2-40B4-BE49-F238E27FC236}">
-                <a16:creationId xmlns:a16="http://schemas.microsoft.com/office/drawing/2014/main" id="{1E72463E-1E21-4D8F-8DEC-57604A02DA66}"/>
+                <a16:creationId xmlns:a16="http://schemas.microsoft.com/office/drawing/2014/main" id="{FD77789B-73C4-4C48-A850-AB5B1B484E27}"/>
               </a:ext>
             </a:extLst>
           </p:cNvPr>
@@ -5265,7 +5265,7 @@
           <p:cNvPr id="12" name="">
             <a:extLst xmlns:a="http://schemas.openxmlformats.org/drawingml/2006/main">
               <a:ext uri="{FF2B5EF4-FFF2-40B4-BE49-F238E27FC236}">
-                <a16:creationId xmlns:a16="http://schemas.microsoft.com/office/drawing/2014/main" id="{BCDE7C4B-5F14-4E1E-A2E3-16A9E0864D5E}"/>
+                <a16:creationId xmlns:a16="http://schemas.microsoft.com/office/drawing/2014/main" id="{947C3B9F-9070-4FFC-A933-AC4E1438C3CD}"/>
               </a:ext>
             </a:extLst>
           </p:cNvPr>
@@ -5315,7 +5315,7 @@
           <p:cNvPr id="13" name="">
             <a:extLst xmlns:a="http://schemas.openxmlformats.org/drawingml/2006/main">
               <a:ext uri="{FF2B5EF4-FFF2-40B4-BE49-F238E27FC236}">
-                <a16:creationId xmlns:a16="http://schemas.microsoft.com/office/drawing/2014/main" id="{3E59A493-E818-461B-9637-467FDB99178F}"/>
+                <a16:creationId xmlns:a16="http://schemas.microsoft.com/office/drawing/2014/main" id="{089443D3-11F8-4202-B588-20F4D0787CAD}"/>
               </a:ext>
             </a:extLst>
           </p:cNvPr>
@@ -5346,7 +5346,7 @@
           <p:cNvPr id="14" name="">
             <a:extLst xmlns:a="http://schemas.openxmlformats.org/drawingml/2006/main">
               <a:ext uri="{FF2B5EF4-FFF2-40B4-BE49-F238E27FC236}">
-                <a16:creationId xmlns:a16="http://schemas.microsoft.com/office/drawing/2014/main" id="{2A24EF90-D95A-482C-85C0-F909320858DD}"/>
+                <a16:creationId xmlns:a16="http://schemas.microsoft.com/office/drawing/2014/main" id="{EDDFA0EE-66CE-46CE-B094-E75919525AB4}"/>
               </a:ext>
             </a:extLst>
           </p:cNvPr>
@@ -5396,7 +5396,7 @@
           <p:cNvPr id="15" name="">
             <a:extLst xmlns:a="http://schemas.openxmlformats.org/drawingml/2006/main">
               <a:ext uri="{FF2B5EF4-FFF2-40B4-BE49-F238E27FC236}">
-                <a16:creationId xmlns:a16="http://schemas.microsoft.com/office/drawing/2014/main" id="{70C6F694-4D0F-478B-AFFE-DC789E924C89}"/>
+                <a16:creationId xmlns:a16="http://schemas.microsoft.com/office/drawing/2014/main" id="{DA984D9A-86D6-482B-AB0C-AE21E696A0DA}"/>
               </a:ext>
             </a:extLst>
           </p:cNvPr>
@@ -5427,7 +5427,7 @@
           <p:cNvPr id="16" name="">
             <a:extLst xmlns:a="http://schemas.openxmlformats.org/drawingml/2006/main">
               <a:ext uri="{FF2B5EF4-FFF2-40B4-BE49-F238E27FC236}">
-                <a16:creationId xmlns:a16="http://schemas.microsoft.com/office/drawing/2014/main" id="{1E8EBA01-21E4-4118-A796-378D05656672}"/>
+                <a16:creationId xmlns:a16="http://schemas.microsoft.com/office/drawing/2014/main" id="{9AB576F4-A709-485B-AF35-192CF216112D}"/>
               </a:ext>
             </a:extLst>
           </p:cNvPr>
@@ -5475,7 +5475,7 @@
     </p:spTree>
     <p:extLst>
       <p:ext uri="{BB962C8B-B14F-4D97-AF65-F5344CB8AC3E}">
-        <p14:creationId xmlns:p14="http://schemas.microsoft.com/office/powerpoint/2010/main" val="2036944029"/>
+        <p14:creationId xmlns:p14="http://schemas.microsoft.com/office/powerpoint/2010/main" val="852632002"/>
       </p:ext>
     </p:extLst>
   </p:cSld>
@@ -5506,7 +5506,7 @@
           <p:cNvPr id="1" name="">
             <a:extLst xmlns:a="http://schemas.openxmlformats.org/drawingml/2006/main">
               <a:ext uri="{FF2B5EF4-FFF2-40B4-BE49-F238E27FC236}">
-                <a16:creationId xmlns:a16="http://schemas.microsoft.com/office/drawing/2014/main" id="{6C1061FB-5932-44CE-9B70-43C708CC1635}"/>
+                <a16:creationId xmlns:a16="http://schemas.microsoft.com/office/drawing/2014/main" id="{BAF09577-2FA3-4280-9892-48B3D97DCADA}"/>
               </a:ext>
             </a:extLst>
           </p:cNvPr>
@@ -5537,7 +5537,7 @@
           <p:cNvPr id="2" name="">
             <a:extLst xmlns:a="http://schemas.openxmlformats.org/drawingml/2006/main">
               <a:ext uri="{FF2B5EF4-FFF2-40B4-BE49-F238E27FC236}">
-                <a16:creationId xmlns:a16="http://schemas.microsoft.com/office/drawing/2014/main" id="{376B3088-1880-45AE-AB75-19EA3B4D231E}"/>
+                <a16:creationId xmlns:a16="http://schemas.microsoft.com/office/drawing/2014/main" id="{42039825-11DC-4AE1-AF2D-FADF1DDE8E9B}"/>
               </a:ext>
             </a:extLst>
           </p:cNvPr>
@@ -5587,7 +5587,7 @@
           <p:cNvPr id="3" name="">
             <a:extLst xmlns:a="http://schemas.openxmlformats.org/drawingml/2006/main">
               <a:ext uri="{FF2B5EF4-FFF2-40B4-BE49-F238E27FC236}">
-                <a16:creationId xmlns:a16="http://schemas.microsoft.com/office/drawing/2014/main" id="{1EBB9C4B-7293-4E3F-9393-D4C004894479}"/>
+                <a16:creationId xmlns:a16="http://schemas.microsoft.com/office/drawing/2014/main" id="{F01496BA-0EA8-4C6D-A4BD-EE1418F35941}"/>
               </a:ext>
             </a:extLst>
           </p:cNvPr>
@@ -5637,7 +5637,7 @@
           <p:cNvPr id="4" name="">
             <a:extLst xmlns:a="http://schemas.openxmlformats.org/drawingml/2006/main">
               <a:ext uri="{FF2B5EF4-FFF2-40B4-BE49-F238E27FC236}">
-                <a16:creationId xmlns:a16="http://schemas.microsoft.com/office/drawing/2014/main" id="{76C6569E-40B8-44F1-8F64-1D2DF993DDE7}"/>
+                <a16:creationId xmlns:a16="http://schemas.microsoft.com/office/drawing/2014/main" id="{4D8EE607-0085-44AB-ACAB-AC3F6668AC7F}"/>
               </a:ext>
             </a:extLst>
           </p:cNvPr>
@@ -5668,7 +5668,7 @@
           <p:cNvPr id="5" name="">
             <a:extLst xmlns:a="http://schemas.openxmlformats.org/drawingml/2006/main">
               <a:ext uri="{FF2B5EF4-FFF2-40B4-BE49-F238E27FC236}">
-                <a16:creationId xmlns:a16="http://schemas.microsoft.com/office/drawing/2014/main" id="{6550C2AF-253C-4291-9384-0FC5F0D3C7B7}"/>
+                <a16:creationId xmlns:a16="http://schemas.microsoft.com/office/drawing/2014/main" id="{E3731CDA-6539-4BAC-AE39-7EA68F36660A}"/>
               </a:ext>
             </a:extLst>
           </p:cNvPr>
@@ -5718,7 +5718,7 @@
           <p:cNvPr id="6" name="">
             <a:extLst xmlns:a="http://schemas.openxmlformats.org/drawingml/2006/main">
               <a:ext uri="{FF2B5EF4-FFF2-40B4-BE49-F238E27FC236}">
-                <a16:creationId xmlns:a16="http://schemas.microsoft.com/office/drawing/2014/main" id="{7E12200F-B476-403E-8D42-7F5DBF9542D6}"/>
+                <a16:creationId xmlns:a16="http://schemas.microsoft.com/office/drawing/2014/main" id="{C5612A05-561D-4DED-977C-6EB7A95F3EF5}"/>
               </a:ext>
             </a:extLst>
           </p:cNvPr>
@@ -5749,7 +5749,7 @@
           <p:cNvPr id="7" name="">
             <a:extLst xmlns:a="http://schemas.openxmlformats.org/drawingml/2006/main">
               <a:ext uri="{FF2B5EF4-FFF2-40B4-BE49-F238E27FC236}">
-                <a16:creationId xmlns:a16="http://schemas.microsoft.com/office/drawing/2014/main" id="{9A892AE4-9D68-4C0B-A772-AE645D96BB30}"/>
+                <a16:creationId xmlns:a16="http://schemas.microsoft.com/office/drawing/2014/main" id="{074EECA7-C10C-4F05-BEB0-E7FE88291FF2}"/>
               </a:ext>
             </a:extLst>
           </p:cNvPr>
@@ -5799,7 +5799,7 @@
           <p:cNvPr id="8" name="">
             <a:extLst xmlns:a="http://schemas.openxmlformats.org/drawingml/2006/main">
               <a:ext uri="{FF2B5EF4-FFF2-40B4-BE49-F238E27FC236}">
-                <a16:creationId xmlns:a16="http://schemas.microsoft.com/office/drawing/2014/main" id="{7F237A7F-2B07-482A-995C-B0AFF5F02505}"/>
+                <a16:creationId xmlns:a16="http://schemas.microsoft.com/office/drawing/2014/main" id="{CBA6E0EC-BC34-4B63-AD52-E8325BA10268}"/>
               </a:ext>
             </a:extLst>
           </p:cNvPr>
@@ -5830,7 +5830,7 @@
           <p:cNvPr id="9" name="">
             <a:extLst xmlns:a="http://schemas.openxmlformats.org/drawingml/2006/main">
               <a:ext uri="{FF2B5EF4-FFF2-40B4-BE49-F238E27FC236}">
-                <a16:creationId xmlns:a16="http://schemas.microsoft.com/office/drawing/2014/main" id="{3DD747C0-9AC5-4830-B4CE-4A0F6A2AB3CF}"/>
+                <a16:creationId xmlns:a16="http://schemas.microsoft.com/office/drawing/2014/main" id="{56C3BBD9-462D-4184-B1DA-74904E391B5B}"/>
               </a:ext>
             </a:extLst>
           </p:cNvPr>
@@ -5880,7 +5880,7 @@
           <p:cNvPr id="10" name="">
             <a:extLst xmlns:a="http://schemas.openxmlformats.org/drawingml/2006/main">
               <a:ext uri="{FF2B5EF4-FFF2-40B4-BE49-F238E27FC236}">
-                <a16:creationId xmlns:a16="http://schemas.microsoft.com/office/drawing/2014/main" id="{F884B6D5-EBC7-476E-9FA3-D073A092D5C3}"/>
+                <a16:creationId xmlns:a16="http://schemas.microsoft.com/office/drawing/2014/main" id="{B4DC9608-9666-4592-8F1F-E966E24E8615}"/>
               </a:ext>
             </a:extLst>
           </p:cNvPr>
@@ -5911,7 +5911,7 @@
           <p:cNvPr id="11" name="">
             <a:extLst xmlns:a="http://schemas.openxmlformats.org/drawingml/2006/main">
               <a:ext uri="{FF2B5EF4-FFF2-40B4-BE49-F238E27FC236}">
-                <a16:creationId xmlns:a16="http://schemas.microsoft.com/office/drawing/2014/main" id="{477DE844-66C4-470F-8E51-83025D170E07}"/>
+                <a16:creationId xmlns:a16="http://schemas.microsoft.com/office/drawing/2014/main" id="{F0E402EB-AB9C-4610-82B7-B22AFCF8962C}"/>
               </a:ext>
             </a:extLst>
           </p:cNvPr>
@@ -5959,7 +5959,7 @@
     </p:spTree>
     <p:extLst>
       <p:ext uri="{BB962C8B-B14F-4D97-AF65-F5344CB8AC3E}">
-        <p14:creationId xmlns:p14="http://schemas.microsoft.com/office/powerpoint/2010/main" val="659824576"/>
+        <p14:creationId xmlns:p14="http://schemas.microsoft.com/office/powerpoint/2010/main" val="1898441148"/>
       </p:ext>
     </p:extLst>
   </p:cSld>
@@ -5990,7 +5990,7 @@
           <p:cNvPr id="1" name="">
             <a:extLst xmlns:a="http://schemas.openxmlformats.org/drawingml/2006/main">
               <a:ext uri="{FF2B5EF4-FFF2-40B4-BE49-F238E27FC236}">
-                <a16:creationId xmlns:a16="http://schemas.microsoft.com/office/drawing/2014/main" id="{09016C81-2134-412C-8577-5766148F5BB3}"/>
+                <a16:creationId xmlns:a16="http://schemas.microsoft.com/office/drawing/2014/main" id="{F376AC13-BB95-4A89-A00F-E97464ABC61F}"/>
               </a:ext>
             </a:extLst>
           </p:cNvPr>
@@ -6021,7 +6021,7 @@
           <p:cNvPr id="2" name="">
             <a:extLst xmlns:a="http://schemas.openxmlformats.org/drawingml/2006/main">
               <a:ext uri="{FF2B5EF4-FFF2-40B4-BE49-F238E27FC236}">
-                <a16:creationId xmlns:a16="http://schemas.microsoft.com/office/drawing/2014/main" id="{465DF28D-E46C-4A39-BA54-6F11EE59A527}"/>
+                <a16:creationId xmlns:a16="http://schemas.microsoft.com/office/drawing/2014/main" id="{CA53E1BA-3425-4675-854F-440694844748}"/>
               </a:ext>
             </a:extLst>
           </p:cNvPr>
@@ -6071,7 +6071,7 @@
           <p:cNvPr id="3" name="">
             <a:extLst xmlns:a="http://schemas.openxmlformats.org/drawingml/2006/main">
               <a:ext uri="{FF2B5EF4-FFF2-40B4-BE49-F238E27FC236}">
-                <a16:creationId xmlns:a16="http://schemas.microsoft.com/office/drawing/2014/main" id="{F8BA2942-3B20-4E8D-A46F-8C79765D828E}"/>
+                <a16:creationId xmlns:a16="http://schemas.microsoft.com/office/drawing/2014/main" id="{E61FB715-232E-417F-8145-64D00A006E8A}"/>
               </a:ext>
             </a:extLst>
           </p:cNvPr>
@@ -6121,7 +6121,7 @@
           <p:cNvPr id="4" name="">
             <a:extLst xmlns:a="http://schemas.openxmlformats.org/drawingml/2006/main">
               <a:ext uri="{FF2B5EF4-FFF2-40B4-BE49-F238E27FC236}">
-                <a16:creationId xmlns:a16="http://schemas.microsoft.com/office/drawing/2014/main" id="{21F6C4BB-7547-40DA-AE89-A890C5518DA7}"/>
+                <a16:creationId xmlns:a16="http://schemas.microsoft.com/office/drawing/2014/main" id="{BBBF1429-884A-4411-9732-B8D11A258D07}"/>
               </a:ext>
             </a:extLst>
           </p:cNvPr>
@@ -6171,7 +6171,7 @@
           <p:cNvPr id="5" name="">
             <a:extLst xmlns:a="http://schemas.openxmlformats.org/drawingml/2006/main">
               <a:ext uri="{FF2B5EF4-FFF2-40B4-BE49-F238E27FC236}">
-                <a16:creationId xmlns:a16="http://schemas.microsoft.com/office/drawing/2014/main" id="{BBE992D8-35A6-4DB4-ABD5-9CE8B8F86193}"/>
+                <a16:creationId xmlns:a16="http://schemas.microsoft.com/office/drawing/2014/main" id="{305F8448-22AD-49EB-823E-574C5631EFB8}"/>
               </a:ext>
             </a:extLst>
           </p:cNvPr>
@@ -6202,7 +6202,7 @@
           <p:cNvPr id="6" name="">
             <a:extLst xmlns:a="http://schemas.openxmlformats.org/drawingml/2006/main">
               <a:ext uri="{FF2B5EF4-FFF2-40B4-BE49-F238E27FC236}">
-                <a16:creationId xmlns:a16="http://schemas.microsoft.com/office/drawing/2014/main" id="{A718BF66-26FE-433B-88A9-7BBA63EBEBF4}"/>
+                <a16:creationId xmlns:a16="http://schemas.microsoft.com/office/drawing/2014/main" id="{4FEA94C3-A853-4017-84A4-605A0EAAF510}"/>
               </a:ext>
             </a:extLst>
           </p:cNvPr>
@@ -6252,7 +6252,7 @@
           <p:cNvPr id="7" name="">
             <a:extLst xmlns:a="http://schemas.openxmlformats.org/drawingml/2006/main">
               <a:ext uri="{FF2B5EF4-FFF2-40B4-BE49-F238E27FC236}">
-                <a16:creationId xmlns:a16="http://schemas.microsoft.com/office/drawing/2014/main" id="{3620185F-ADA1-4E55-B409-49B744D81EE9}"/>
+                <a16:creationId xmlns:a16="http://schemas.microsoft.com/office/drawing/2014/main" id="{97565405-7A20-49D9-A799-91F8BCFF2729}"/>
               </a:ext>
             </a:extLst>
           </p:cNvPr>
@@ -6283,7 +6283,7 @@
           <p:cNvPr id="8" name="">
             <a:extLst xmlns:a="http://schemas.openxmlformats.org/drawingml/2006/main">
               <a:ext uri="{FF2B5EF4-FFF2-40B4-BE49-F238E27FC236}">
-                <a16:creationId xmlns:a16="http://schemas.microsoft.com/office/drawing/2014/main" id="{6A124AB4-E980-4C61-BA92-EAB8C36CF17A}"/>
+                <a16:creationId xmlns:a16="http://schemas.microsoft.com/office/drawing/2014/main" id="{0D073973-1564-4A48-A6EF-FD8A9E3FA143}"/>
               </a:ext>
             </a:extLst>
           </p:cNvPr>
@@ -6333,7 +6333,7 @@
           <p:cNvPr id="9" name="">
             <a:extLst xmlns:a="http://schemas.openxmlformats.org/drawingml/2006/main">
               <a:ext uri="{FF2B5EF4-FFF2-40B4-BE49-F238E27FC236}">
-                <a16:creationId xmlns:a16="http://schemas.microsoft.com/office/drawing/2014/main" id="{7414E383-F025-40EC-8E6A-7871C280FBA6}"/>
+                <a16:creationId xmlns:a16="http://schemas.microsoft.com/office/drawing/2014/main" id="{347B776F-E98D-4809-8706-DA7FABC92EBD}"/>
               </a:ext>
             </a:extLst>
           </p:cNvPr>
@@ -6364,7 +6364,7 @@
           <p:cNvPr id="10" name="">
             <a:extLst xmlns:a="http://schemas.openxmlformats.org/drawingml/2006/main">
               <a:ext uri="{FF2B5EF4-FFF2-40B4-BE49-F238E27FC236}">
-                <a16:creationId xmlns:a16="http://schemas.microsoft.com/office/drawing/2014/main" id="{248F1D9E-5AC9-4D2A-815D-33E1DA37B54B}"/>
+                <a16:creationId xmlns:a16="http://schemas.microsoft.com/office/drawing/2014/main" id="{64AD82B9-A107-43B7-9FE7-FEA022DFFD38}"/>
               </a:ext>
             </a:extLst>
           </p:cNvPr>
@@ -6418,7 +6418,7 @@
           <p:nvPr/>
         </p:nvPicPr>
         <p:blipFill>
-          <a:blip xmlns:r="http://schemas.openxmlformats.org/officeDocument/2006/relationships" xmlns:a="http://schemas.openxmlformats.org/drawingml/2006/main" r:embed="Rd5532243cfea43cb"/>
+          <a:blip xmlns:r="http://schemas.openxmlformats.org/officeDocument/2006/relationships" xmlns:a="http://schemas.openxmlformats.org/drawingml/2006/main" r:embed="Rcb6dbff1834e44bd"/>
           <a:stretch xmlns:a="http://schemas.openxmlformats.org/drawingml/2006/main"/>
         </p:blipFill>
         <p:spPr>
@@ -6436,7 +6436,7 @@
           <p:cNvPr id="12" name="">
             <a:extLst xmlns:a="http://schemas.openxmlformats.org/drawingml/2006/main">
               <a:ext uri="{FF2B5EF4-FFF2-40B4-BE49-F238E27FC236}">
-                <a16:creationId xmlns:a16="http://schemas.microsoft.com/office/drawing/2014/main" id="{FE334FEA-D4E6-4DD0-8178-68DAAF99769D}"/>
+                <a16:creationId xmlns:a16="http://schemas.microsoft.com/office/drawing/2014/main" id="{6497798B-DC9A-4990-9FBD-86254C3F8F5A}"/>
               </a:ext>
             </a:extLst>
           </p:cNvPr>
@@ -6490,7 +6490,7 @@
           <p:nvPr/>
         </p:nvPicPr>
         <p:blipFill>
-          <a:blip xmlns:r="http://schemas.openxmlformats.org/officeDocument/2006/relationships" xmlns:a="http://schemas.openxmlformats.org/drawingml/2006/main" r:embed="R6e25ebbec3a44c33"/>
+          <a:blip xmlns:r="http://schemas.openxmlformats.org/officeDocument/2006/relationships" xmlns:a="http://schemas.openxmlformats.org/drawingml/2006/main" r:embed="Re55841c490a944d6"/>
           <a:stretch xmlns:a="http://schemas.openxmlformats.org/drawingml/2006/main"/>
         </p:blipFill>
         <p:spPr>
@@ -6508,7 +6508,7 @@
           <p:cNvPr id="14" name="">
             <a:extLst xmlns:a="http://schemas.openxmlformats.org/drawingml/2006/main">
               <a:ext uri="{FF2B5EF4-FFF2-40B4-BE49-F238E27FC236}">
-                <a16:creationId xmlns:a16="http://schemas.microsoft.com/office/drawing/2014/main" id="{3701A6DB-9D60-42BA-A1BC-1551048C9BA2}"/>
+                <a16:creationId xmlns:a16="http://schemas.microsoft.com/office/drawing/2014/main" id="{9807488F-673B-4BB1-A2CB-EDFF5B8498EE}"/>
               </a:ext>
             </a:extLst>
           </p:cNvPr>
@@ -6558,7 +6558,7 @@
           <p:cNvPr id="15" name="">
             <a:extLst xmlns:a="http://schemas.openxmlformats.org/drawingml/2006/main">
               <a:ext uri="{FF2B5EF4-FFF2-40B4-BE49-F238E27FC236}">
-                <a16:creationId xmlns:a16="http://schemas.microsoft.com/office/drawing/2014/main" id="{5003B240-8B46-4B6F-B3C2-BBBEE7D0CFCE}"/>
+                <a16:creationId xmlns:a16="http://schemas.microsoft.com/office/drawing/2014/main" id="{B613EE25-6C3E-4181-A0FD-0FBC00EDAF43}"/>
               </a:ext>
             </a:extLst>
           </p:cNvPr>
@@ -6606,7 +6606,7 @@
     </p:spTree>
     <p:extLst>
       <p:ext uri="{BB962C8B-B14F-4D97-AF65-F5344CB8AC3E}">
-        <p14:creationId xmlns:p14="http://schemas.microsoft.com/office/powerpoint/2010/main" val="953094349"/>
+        <p14:creationId xmlns:p14="http://schemas.microsoft.com/office/powerpoint/2010/main" val="1101075716"/>
       </p:ext>
     </p:extLst>
   </p:cSld>
@@ -6637,7 +6637,7 @@
           <p:cNvPr id="1" name="">
             <a:extLst xmlns:a="http://schemas.openxmlformats.org/drawingml/2006/main">
               <a:ext uri="{FF2B5EF4-FFF2-40B4-BE49-F238E27FC236}">
-                <a16:creationId xmlns:a16="http://schemas.microsoft.com/office/drawing/2014/main" id="{34F3D9CA-F47D-42CB-A4CB-9D3E929465DE}"/>
+                <a16:creationId xmlns:a16="http://schemas.microsoft.com/office/drawing/2014/main" id="{0ED1DF22-0E9D-4B6B-9FA1-549ADCFF96B2}"/>
               </a:ext>
             </a:extLst>
           </p:cNvPr>
@@ -6668,7 +6668,7 @@
           <p:cNvPr id="2" name="">
             <a:extLst xmlns:a="http://schemas.openxmlformats.org/drawingml/2006/main">
               <a:ext uri="{FF2B5EF4-FFF2-40B4-BE49-F238E27FC236}">
-                <a16:creationId xmlns:a16="http://schemas.microsoft.com/office/drawing/2014/main" id="{819D2DF4-7B40-487C-A551-47F65A8CD8BF}"/>
+                <a16:creationId xmlns:a16="http://schemas.microsoft.com/office/drawing/2014/main" id="{0DA83B66-7260-4839-98D5-C93235F7766B}"/>
               </a:ext>
             </a:extLst>
           </p:cNvPr>
@@ -6718,7 +6718,7 @@
           <p:cNvPr id="3" name="">
             <a:extLst xmlns:a="http://schemas.openxmlformats.org/drawingml/2006/main">
               <a:ext uri="{FF2B5EF4-FFF2-40B4-BE49-F238E27FC236}">
-                <a16:creationId xmlns:a16="http://schemas.microsoft.com/office/drawing/2014/main" id="{1D0EDA87-0FE9-4A9B-A795-D52C924F94DC}"/>
+                <a16:creationId xmlns:a16="http://schemas.microsoft.com/office/drawing/2014/main" id="{8EFB4025-365D-4082-9FF6-379440DA7AA1}"/>
               </a:ext>
             </a:extLst>
           </p:cNvPr>
@@ -6768,7 +6768,7 @@
           <p:cNvPr id="4" name="">
             <a:extLst xmlns:a="http://schemas.openxmlformats.org/drawingml/2006/main">
               <a:ext uri="{FF2B5EF4-FFF2-40B4-BE49-F238E27FC236}">
-                <a16:creationId xmlns:a16="http://schemas.microsoft.com/office/drawing/2014/main" id="{DDE5F221-3982-4804-AAC7-869EC4C0B375}"/>
+                <a16:creationId xmlns:a16="http://schemas.microsoft.com/office/drawing/2014/main" id="{2CD1813C-B4B4-4E66-996D-39FED2ECD75C}"/>
               </a:ext>
             </a:extLst>
           </p:cNvPr>
@@ -6799,7 +6799,7 @@
           <p:cNvPr id="5" name="">
             <a:extLst xmlns:a="http://schemas.openxmlformats.org/drawingml/2006/main">
               <a:ext uri="{FF2B5EF4-FFF2-40B4-BE49-F238E27FC236}">
-                <a16:creationId xmlns:a16="http://schemas.microsoft.com/office/drawing/2014/main" id="{9C4BD703-5739-4284-94A3-4A8CF970904B}"/>
+                <a16:creationId xmlns:a16="http://schemas.microsoft.com/office/drawing/2014/main" id="{DB63170A-15E2-4CF8-B94E-A0072DE22269}"/>
               </a:ext>
             </a:extLst>
           </p:cNvPr>
@@ -6849,7 +6849,7 @@
           <p:cNvPr id="6" name="">
             <a:extLst xmlns:a="http://schemas.openxmlformats.org/drawingml/2006/main">
               <a:ext uri="{FF2B5EF4-FFF2-40B4-BE49-F238E27FC236}">
-                <a16:creationId xmlns:a16="http://schemas.microsoft.com/office/drawing/2014/main" id="{DAB0BA9B-AB8F-47BA-81D9-6DBC59F1CE05}"/>
+                <a16:creationId xmlns:a16="http://schemas.microsoft.com/office/drawing/2014/main" id="{693C49D6-3803-40B4-B76A-E7BB431A56B9}"/>
               </a:ext>
             </a:extLst>
           </p:cNvPr>
@@ -6880,7 +6880,7 @@
           <p:cNvPr id="7" name="">
             <a:extLst xmlns:a="http://schemas.openxmlformats.org/drawingml/2006/main">
               <a:ext uri="{FF2B5EF4-FFF2-40B4-BE49-F238E27FC236}">
-                <a16:creationId xmlns:a16="http://schemas.microsoft.com/office/drawing/2014/main" id="{C715C021-1917-4ED4-A797-E82FF43066B2}"/>
+                <a16:creationId xmlns:a16="http://schemas.microsoft.com/office/drawing/2014/main" id="{119631A4-3E7A-4D04-8C51-3125AC59E78D}"/>
               </a:ext>
             </a:extLst>
           </p:cNvPr>
@@ -6930,7 +6930,7 @@
           <p:cNvPr id="8" name="">
             <a:extLst xmlns:a="http://schemas.openxmlformats.org/drawingml/2006/main">
               <a:ext uri="{FF2B5EF4-FFF2-40B4-BE49-F238E27FC236}">
-                <a16:creationId xmlns:a16="http://schemas.microsoft.com/office/drawing/2014/main" id="{D2FA0AE6-71CC-40DD-92D2-BA7A3C4EBF85}"/>
+                <a16:creationId xmlns:a16="http://schemas.microsoft.com/office/drawing/2014/main" id="{36DBF321-456D-4A69-AD39-3309D897DEFC}"/>
               </a:ext>
             </a:extLst>
           </p:cNvPr>
@@ -6961,7 +6961,7 @@
           <p:cNvPr id="9" name="">
             <a:extLst xmlns:a="http://schemas.openxmlformats.org/drawingml/2006/main">
               <a:ext uri="{FF2B5EF4-FFF2-40B4-BE49-F238E27FC236}">
-                <a16:creationId xmlns:a16="http://schemas.microsoft.com/office/drawing/2014/main" id="{6802DFE9-0486-43A2-B275-FF499D1E49EE}"/>
+                <a16:creationId xmlns:a16="http://schemas.microsoft.com/office/drawing/2014/main" id="{24E8F3D4-AAB1-43AB-970E-DC2BA9D86CB4}"/>
               </a:ext>
             </a:extLst>
           </p:cNvPr>
@@ -7009,7 +7009,7 @@
     </p:spTree>
     <p:extLst>
       <p:ext uri="{BB962C8B-B14F-4D97-AF65-F5344CB8AC3E}">
-        <p14:creationId xmlns:p14="http://schemas.microsoft.com/office/powerpoint/2010/main" val="1630891385"/>
+        <p14:creationId xmlns:p14="http://schemas.microsoft.com/office/powerpoint/2010/main" val="764668958"/>
       </p:ext>
     </p:extLst>
   </p:cSld>
@@ -7040,7 +7040,7 @@
           <p:cNvPr id="1" name="">
             <a:extLst xmlns:a="http://schemas.openxmlformats.org/drawingml/2006/main">
               <a:ext uri="{FF2B5EF4-FFF2-40B4-BE49-F238E27FC236}">
-                <a16:creationId xmlns:a16="http://schemas.microsoft.com/office/drawing/2014/main" id="{6DD4A24C-3F57-4B22-B00F-07E6E9CDEBE1}"/>
+                <a16:creationId xmlns:a16="http://schemas.microsoft.com/office/drawing/2014/main" id="{17CE1339-BD26-4E3C-BC45-6B2611513C98}"/>
               </a:ext>
             </a:extLst>
           </p:cNvPr>
@@ -7071,7 +7071,7 @@
           <p:cNvPr id="2" name="">
             <a:extLst xmlns:a="http://schemas.openxmlformats.org/drawingml/2006/main">
               <a:ext uri="{FF2B5EF4-FFF2-40B4-BE49-F238E27FC236}">
-                <a16:creationId xmlns:a16="http://schemas.microsoft.com/office/drawing/2014/main" id="{391A2EB3-1697-4DF7-AFE9-74B57E78F511}"/>
+                <a16:creationId xmlns:a16="http://schemas.microsoft.com/office/drawing/2014/main" id="{6FED6CEF-C6D4-4C7C-90D0-D958029F5A97}"/>
               </a:ext>
             </a:extLst>
           </p:cNvPr>
@@ -7121,7 +7121,7 @@
           <p:cNvPr id="3" name="">
             <a:extLst xmlns:a="http://schemas.openxmlformats.org/drawingml/2006/main">
               <a:ext uri="{FF2B5EF4-FFF2-40B4-BE49-F238E27FC236}">
-                <a16:creationId xmlns:a16="http://schemas.microsoft.com/office/drawing/2014/main" id="{62352D1A-55E4-4CDA-BF75-E1FD66689D1C}"/>
+                <a16:creationId xmlns:a16="http://schemas.microsoft.com/office/drawing/2014/main" id="{EF065431-D766-4013-9CE7-46ECE93DF5B0}"/>
               </a:ext>
             </a:extLst>
           </p:cNvPr>
@@ -7171,7 +7171,7 @@
           <p:cNvPr id="4" name="">
             <a:extLst xmlns:a="http://schemas.openxmlformats.org/drawingml/2006/main">
               <a:ext uri="{FF2B5EF4-FFF2-40B4-BE49-F238E27FC236}">
-                <a16:creationId xmlns:a16="http://schemas.microsoft.com/office/drawing/2014/main" id="{FA528607-650B-42EC-87EC-95CF00E48523}"/>
+                <a16:creationId xmlns:a16="http://schemas.microsoft.com/office/drawing/2014/main" id="{A0849D10-A367-4A79-AEA2-D5B1C9B2174F}"/>
               </a:ext>
             </a:extLst>
           </p:cNvPr>
@@ -7206,7 +7206,7 @@
           <p:cNvPr id="5" name="">
             <a:extLst xmlns:a="http://schemas.openxmlformats.org/drawingml/2006/main">
               <a:ext uri="{FF2B5EF4-FFF2-40B4-BE49-F238E27FC236}">
-                <a16:creationId xmlns:a16="http://schemas.microsoft.com/office/drawing/2014/main" id="{9BB335A5-803A-475B-BC48-DEBFEA4EB1B2}"/>
+                <a16:creationId xmlns:a16="http://schemas.microsoft.com/office/drawing/2014/main" id="{029DAB45-6E65-437B-8EA8-FC22776CA70A}"/>
               </a:ext>
             </a:extLst>
           </p:cNvPr>
@@ -7256,7 +7256,7 @@
           <p:cNvPr id="6" name="">
             <a:extLst xmlns:a="http://schemas.openxmlformats.org/drawingml/2006/main">
               <a:ext uri="{FF2B5EF4-FFF2-40B4-BE49-F238E27FC236}">
-                <a16:creationId xmlns:a16="http://schemas.microsoft.com/office/drawing/2014/main" id="{2BF01823-59BC-4954-BBFF-C34F8609E6B9}"/>
+                <a16:creationId xmlns:a16="http://schemas.microsoft.com/office/drawing/2014/main" id="{09786CD7-A9F0-4A42-86D5-B12FCAFA7B62}"/>
               </a:ext>
             </a:extLst>
           </p:cNvPr>
@@ -7306,7 +7306,7 @@
           <p:cNvPr id="7" name="">
             <a:extLst xmlns:a="http://schemas.openxmlformats.org/drawingml/2006/main">
               <a:ext uri="{FF2B5EF4-FFF2-40B4-BE49-F238E27FC236}">
-                <a16:creationId xmlns:a16="http://schemas.microsoft.com/office/drawing/2014/main" id="{27CC21C1-278A-4672-8CBC-9070F30DC45F}"/>
+                <a16:creationId xmlns:a16="http://schemas.microsoft.com/office/drawing/2014/main" id="{561EB627-5D41-4CFD-A31E-54A352964956}"/>
               </a:ext>
             </a:extLst>
           </p:cNvPr>
@@ -7341,7 +7341,7 @@
           <p:cNvPr id="8" name="">
             <a:extLst xmlns:a="http://schemas.openxmlformats.org/drawingml/2006/main">
               <a:ext uri="{FF2B5EF4-FFF2-40B4-BE49-F238E27FC236}">
-                <a16:creationId xmlns:a16="http://schemas.microsoft.com/office/drawing/2014/main" id="{EB1F954B-9E2F-4102-9407-DFA9B8ACFC52}"/>
+                <a16:creationId xmlns:a16="http://schemas.microsoft.com/office/drawing/2014/main" id="{9CC9AA16-62C7-4194-BB7E-CEBF7D560F97}"/>
               </a:ext>
             </a:extLst>
           </p:cNvPr>
@@ -7391,7 +7391,7 @@
           <p:cNvPr id="9" name="">
             <a:extLst xmlns:a="http://schemas.openxmlformats.org/drawingml/2006/main">
               <a:ext uri="{FF2B5EF4-FFF2-40B4-BE49-F238E27FC236}">
-                <a16:creationId xmlns:a16="http://schemas.microsoft.com/office/drawing/2014/main" id="{09526ADD-5F6D-41A7-9D7F-C507803ECFB8}"/>
+                <a16:creationId xmlns:a16="http://schemas.microsoft.com/office/drawing/2014/main" id="{A7F7B73F-BDF7-4AEB-8783-F268F0578FF4}"/>
               </a:ext>
             </a:extLst>
           </p:cNvPr>
@@ -7441,7 +7441,7 @@
           <p:cNvPr id="10" name="">
             <a:extLst xmlns:a="http://schemas.openxmlformats.org/drawingml/2006/main">
               <a:ext uri="{FF2B5EF4-FFF2-40B4-BE49-F238E27FC236}">
-                <a16:creationId xmlns:a16="http://schemas.microsoft.com/office/drawing/2014/main" id="{8D207687-A9E2-499E-88C2-5AF741AF3564}"/>
+                <a16:creationId xmlns:a16="http://schemas.microsoft.com/office/drawing/2014/main" id="{4E35370F-6202-4B73-9247-65E0A9FCBCDA}"/>
               </a:ext>
             </a:extLst>
           </p:cNvPr>
@@ -7476,7 +7476,7 @@
           <p:cNvPr id="11" name="">
             <a:extLst xmlns:a="http://schemas.openxmlformats.org/drawingml/2006/main">
               <a:ext uri="{FF2B5EF4-FFF2-40B4-BE49-F238E27FC236}">
-                <a16:creationId xmlns:a16="http://schemas.microsoft.com/office/drawing/2014/main" id="{3E052AC3-3DCF-474F-9E29-B1044C39B38F}"/>
+                <a16:creationId xmlns:a16="http://schemas.microsoft.com/office/drawing/2014/main" id="{9354F536-BC59-4D89-97EB-5CCC4975C91E}"/>
               </a:ext>
             </a:extLst>
           </p:cNvPr>
@@ -7526,7 +7526,7 @@
           <p:cNvPr id="12" name="">
             <a:extLst xmlns:a="http://schemas.openxmlformats.org/drawingml/2006/main">
               <a:ext uri="{FF2B5EF4-FFF2-40B4-BE49-F238E27FC236}">
-                <a16:creationId xmlns:a16="http://schemas.microsoft.com/office/drawing/2014/main" id="{035C993C-0406-4DFA-8F05-D1DF855D302C}"/>
+                <a16:creationId xmlns:a16="http://schemas.microsoft.com/office/drawing/2014/main" id="{E289BA97-70C4-4CD2-A70F-0FCAE85A7ACC}"/>
               </a:ext>
             </a:extLst>
           </p:cNvPr>
@@ -7576,7 +7576,7 @@
           <p:cNvPr id="13" name="">
             <a:extLst xmlns:a="http://schemas.openxmlformats.org/drawingml/2006/main">
               <a:ext uri="{FF2B5EF4-FFF2-40B4-BE49-F238E27FC236}">
-                <a16:creationId xmlns:a16="http://schemas.microsoft.com/office/drawing/2014/main" id="{02A0BFE8-0ED3-454C-8DB0-CBD217D10FB2}"/>
+                <a16:creationId xmlns:a16="http://schemas.microsoft.com/office/drawing/2014/main" id="{31D1CB46-B78E-4730-BCA2-1FA0D27985F5}"/>
               </a:ext>
             </a:extLst>
           </p:cNvPr>
@@ -7607,7 +7607,7 @@
           <p:cNvPr id="14" name="">
             <a:extLst xmlns:a="http://schemas.openxmlformats.org/drawingml/2006/main">
               <a:ext uri="{FF2B5EF4-FFF2-40B4-BE49-F238E27FC236}">
-                <a16:creationId xmlns:a16="http://schemas.microsoft.com/office/drawing/2014/main" id="{D5355FAD-F43E-4DAE-9BD9-098B9BD101C1}"/>
+                <a16:creationId xmlns:a16="http://schemas.microsoft.com/office/drawing/2014/main" id="{07CC899C-90A1-4F1A-BBFC-00D8D275BF05}"/>
               </a:ext>
             </a:extLst>
           </p:cNvPr>
@@ -7657,7 +7657,7 @@
           <p:cNvPr id="15" name="">
             <a:extLst xmlns:a="http://schemas.openxmlformats.org/drawingml/2006/main">
               <a:ext uri="{FF2B5EF4-FFF2-40B4-BE49-F238E27FC236}">
-                <a16:creationId xmlns:a16="http://schemas.microsoft.com/office/drawing/2014/main" id="{824BC64E-DB82-4CD8-9367-8F162A004C90}"/>
+                <a16:creationId xmlns:a16="http://schemas.microsoft.com/office/drawing/2014/main" id="{668BDE28-3A13-454B-85A7-3B4D93026B99}"/>
               </a:ext>
             </a:extLst>
           </p:cNvPr>
@@ -7688,7 +7688,7 @@
           <p:cNvPr id="16" name="">
             <a:extLst xmlns:a="http://schemas.openxmlformats.org/drawingml/2006/main">
               <a:ext uri="{FF2B5EF4-FFF2-40B4-BE49-F238E27FC236}">
-                <a16:creationId xmlns:a16="http://schemas.microsoft.com/office/drawing/2014/main" id="{0522FE79-7835-4141-8374-90C4F4CE867A}"/>
+                <a16:creationId xmlns:a16="http://schemas.microsoft.com/office/drawing/2014/main" id="{415895A2-9115-43DA-A86F-66949E5D1D41}"/>
               </a:ext>
             </a:extLst>
           </p:cNvPr>
@@ -7738,7 +7738,7 @@
           <p:cNvPr id="17" name="">
             <a:extLst xmlns:a="http://schemas.openxmlformats.org/drawingml/2006/main">
               <a:ext uri="{FF2B5EF4-FFF2-40B4-BE49-F238E27FC236}">
-                <a16:creationId xmlns:a16="http://schemas.microsoft.com/office/drawing/2014/main" id="{F1591C22-AA16-4F61-9722-DB72F27BF439}"/>
+                <a16:creationId xmlns:a16="http://schemas.microsoft.com/office/drawing/2014/main" id="{914459DF-5838-4DA5-8CA7-165C1D55AE69}"/>
               </a:ext>
             </a:extLst>
           </p:cNvPr>
@@ -7769,7 +7769,7 @@
           <p:cNvPr id="18" name="">
             <a:extLst xmlns:a="http://schemas.openxmlformats.org/drawingml/2006/main">
               <a:ext uri="{FF2B5EF4-FFF2-40B4-BE49-F238E27FC236}">
-                <a16:creationId xmlns:a16="http://schemas.microsoft.com/office/drawing/2014/main" id="{30198BD9-EDE8-41AB-BF88-41469A31AD6A}"/>
+                <a16:creationId xmlns:a16="http://schemas.microsoft.com/office/drawing/2014/main" id="{A4447F0F-DF2D-4A46-865F-AA667844C5D5}"/>
               </a:ext>
             </a:extLst>
           </p:cNvPr>
@@ -7817,7 +7817,7 @@
     </p:spTree>
     <p:extLst>
       <p:ext uri="{BB962C8B-B14F-4D97-AF65-F5344CB8AC3E}">
-        <p14:creationId xmlns:p14="http://schemas.microsoft.com/office/powerpoint/2010/main" val="1176940270"/>
+        <p14:creationId xmlns:p14="http://schemas.microsoft.com/office/powerpoint/2010/main" val="2006900346"/>
       </p:ext>
     </p:extLst>
   </p:cSld>
@@ -7848,7 +7848,7 @@
           <p:cNvPr id="1" name="">
             <a:extLst xmlns:a="http://schemas.openxmlformats.org/drawingml/2006/main">
               <a:ext uri="{FF2B5EF4-FFF2-40B4-BE49-F238E27FC236}">
-                <a16:creationId xmlns:a16="http://schemas.microsoft.com/office/drawing/2014/main" id="{DE17429E-8188-470F-94CB-8C5B3C5BAB02}"/>
+                <a16:creationId xmlns:a16="http://schemas.microsoft.com/office/drawing/2014/main" id="{469E8401-F994-440C-AAB0-330135092C0E}"/>
               </a:ext>
             </a:extLst>
           </p:cNvPr>
@@ -7879,7 +7879,7 @@
           <p:cNvPr id="2" name="">
             <a:extLst xmlns:a="http://schemas.openxmlformats.org/drawingml/2006/main">
               <a:ext uri="{FF2B5EF4-FFF2-40B4-BE49-F238E27FC236}">
-                <a16:creationId xmlns:a16="http://schemas.microsoft.com/office/drawing/2014/main" id="{B32784AF-3D7F-4C72-8352-2590F199D116}"/>
+                <a16:creationId xmlns:a16="http://schemas.microsoft.com/office/drawing/2014/main" id="{67D36BB5-EC92-4126-8D8D-E9AC9C7B63B8}"/>
               </a:ext>
             </a:extLst>
           </p:cNvPr>
@@ -7929,7 +7929,7 @@
           <p:cNvPr id="3" name="">
             <a:extLst xmlns:a="http://schemas.openxmlformats.org/drawingml/2006/main">
               <a:ext uri="{FF2B5EF4-FFF2-40B4-BE49-F238E27FC236}">
-                <a16:creationId xmlns:a16="http://schemas.microsoft.com/office/drawing/2014/main" id="{0E3C55C9-41B7-45D9-A0C0-E7BE54ED490B}"/>
+                <a16:creationId xmlns:a16="http://schemas.microsoft.com/office/drawing/2014/main" id="{BFB203AC-C52A-4D0F-97CF-C9261E21B1A7}"/>
               </a:ext>
             </a:extLst>
           </p:cNvPr>
@@ -7979,7 +7979,7 @@
           <p:cNvPr id="4" name="">
             <a:extLst xmlns:a="http://schemas.openxmlformats.org/drawingml/2006/main">
               <a:ext uri="{FF2B5EF4-FFF2-40B4-BE49-F238E27FC236}">
-                <a16:creationId xmlns:a16="http://schemas.microsoft.com/office/drawing/2014/main" id="{CD6B4B1A-0298-429B-90F6-33B46414B612}"/>
+                <a16:creationId xmlns:a16="http://schemas.microsoft.com/office/drawing/2014/main" id="{A7470BB8-165B-495A-BBC8-3C2D9262AB22}"/>
               </a:ext>
             </a:extLst>
           </p:cNvPr>
@@ -8010,7 +8010,7 @@
           <p:cNvPr id="5" name="">
             <a:extLst xmlns:a="http://schemas.openxmlformats.org/drawingml/2006/main">
               <a:ext uri="{FF2B5EF4-FFF2-40B4-BE49-F238E27FC236}">
-                <a16:creationId xmlns:a16="http://schemas.microsoft.com/office/drawing/2014/main" id="{EA2F2A69-65FE-481A-B978-3D59FDA11314}"/>
+                <a16:creationId xmlns:a16="http://schemas.microsoft.com/office/drawing/2014/main" id="{227EC956-A96A-4349-AD9A-B19C6068085A}"/>
               </a:ext>
             </a:extLst>
           </p:cNvPr>
@@ -8060,7 +8060,7 @@
           <p:cNvPr id="6" name="">
             <a:extLst xmlns:a="http://schemas.openxmlformats.org/drawingml/2006/main">
               <a:ext uri="{FF2B5EF4-FFF2-40B4-BE49-F238E27FC236}">
-                <a16:creationId xmlns:a16="http://schemas.microsoft.com/office/drawing/2014/main" id="{E41FFC71-0756-406D-866E-A3BF61FCAFBA}"/>
+                <a16:creationId xmlns:a16="http://schemas.microsoft.com/office/drawing/2014/main" id="{918A8611-DD56-4273-819C-8FC0AA5A1512}"/>
               </a:ext>
             </a:extLst>
           </p:cNvPr>
@@ -8091,7 +8091,7 @@
           <p:cNvPr id="7" name="">
             <a:extLst xmlns:a="http://schemas.openxmlformats.org/drawingml/2006/main">
               <a:ext uri="{FF2B5EF4-FFF2-40B4-BE49-F238E27FC236}">
-                <a16:creationId xmlns:a16="http://schemas.microsoft.com/office/drawing/2014/main" id="{B1FCA316-7521-4951-AC69-7238609AFCF2}"/>
+                <a16:creationId xmlns:a16="http://schemas.microsoft.com/office/drawing/2014/main" id="{1650F25C-803C-4E3F-B774-1CDB8322B9A7}"/>
               </a:ext>
             </a:extLst>
           </p:cNvPr>
@@ -8141,7 +8141,7 @@
           <p:cNvPr id="8" name="">
             <a:extLst xmlns:a="http://schemas.openxmlformats.org/drawingml/2006/main">
               <a:ext uri="{FF2B5EF4-FFF2-40B4-BE49-F238E27FC236}">
-                <a16:creationId xmlns:a16="http://schemas.microsoft.com/office/drawing/2014/main" id="{174BA035-F9CE-45F3-BF5B-1B75F6775795}"/>
+                <a16:creationId xmlns:a16="http://schemas.microsoft.com/office/drawing/2014/main" id="{10859B24-5D0E-4913-964D-0949AB790826}"/>
               </a:ext>
             </a:extLst>
           </p:cNvPr>
@@ -8172,7 +8172,7 @@
           <p:cNvPr id="9" name="">
             <a:extLst xmlns:a="http://schemas.openxmlformats.org/drawingml/2006/main">
               <a:ext uri="{FF2B5EF4-FFF2-40B4-BE49-F238E27FC236}">
-                <a16:creationId xmlns:a16="http://schemas.microsoft.com/office/drawing/2014/main" id="{321EF86E-15DB-4F29-BD1B-2A605D6DD0B3}"/>
+                <a16:creationId xmlns:a16="http://schemas.microsoft.com/office/drawing/2014/main" id="{DFC53FBC-D475-4D76-9C0B-96139CF5A552}"/>
               </a:ext>
             </a:extLst>
           </p:cNvPr>
@@ -8220,7 +8220,7 @@
     </p:spTree>
     <p:extLst>
       <p:ext uri="{BB962C8B-B14F-4D97-AF65-F5344CB8AC3E}">
-        <p14:creationId xmlns:p14="http://schemas.microsoft.com/office/powerpoint/2010/main" val="389280096"/>
+        <p14:creationId xmlns:p14="http://schemas.microsoft.com/office/powerpoint/2010/main" val="43349937"/>
       </p:ext>
     </p:extLst>
   </p:cSld>
@@ -8251,7 +8251,7 @@
           <p:cNvPr id="1" name="">
             <a:extLst xmlns:a="http://schemas.openxmlformats.org/drawingml/2006/main">
               <a:ext uri="{FF2B5EF4-FFF2-40B4-BE49-F238E27FC236}">
-                <a16:creationId xmlns:a16="http://schemas.microsoft.com/office/drawing/2014/main" id="{2B32E57C-DB51-4CB6-9129-45514F52F30B}"/>
+                <a16:creationId xmlns:a16="http://schemas.microsoft.com/office/drawing/2014/main" id="{4F87140D-8520-4C3B-9B4B-870386EA4F72}"/>
               </a:ext>
             </a:extLst>
           </p:cNvPr>
@@ -8282,7 +8282,7 @@
           <p:cNvPr id="2" name="">
             <a:extLst xmlns:a="http://schemas.openxmlformats.org/drawingml/2006/main">
               <a:ext uri="{FF2B5EF4-FFF2-40B4-BE49-F238E27FC236}">
-                <a16:creationId xmlns:a16="http://schemas.microsoft.com/office/drawing/2014/main" id="{48D784B0-EDA0-439B-BD03-FFF3E3AE1654}"/>
+                <a16:creationId xmlns:a16="http://schemas.microsoft.com/office/drawing/2014/main" id="{E6266873-5EE3-4286-BC74-3FBAAB79E4E1}"/>
               </a:ext>
             </a:extLst>
           </p:cNvPr>
@@ -8332,7 +8332,7 @@
           <p:cNvPr id="3" name="">
             <a:extLst xmlns:a="http://schemas.openxmlformats.org/drawingml/2006/main">
               <a:ext uri="{FF2B5EF4-FFF2-40B4-BE49-F238E27FC236}">
-                <a16:creationId xmlns:a16="http://schemas.microsoft.com/office/drawing/2014/main" id="{A8BA36E1-4D5F-4991-AE23-FEE24F7D0FF3}"/>
+                <a16:creationId xmlns:a16="http://schemas.microsoft.com/office/drawing/2014/main" id="{2E92217F-D6E3-4436-B338-7D85868F4908}"/>
               </a:ext>
             </a:extLst>
           </p:cNvPr>
@@ -8382,7 +8382,7 @@
           <p:cNvPr id="4" name="">
             <a:extLst xmlns:a="http://schemas.openxmlformats.org/drawingml/2006/main">
               <a:ext uri="{FF2B5EF4-FFF2-40B4-BE49-F238E27FC236}">
-                <a16:creationId xmlns:a16="http://schemas.microsoft.com/office/drawing/2014/main" id="{E27EA19B-A045-4D39-A0B4-C613E68937AD}"/>
+                <a16:creationId xmlns:a16="http://schemas.microsoft.com/office/drawing/2014/main" id="{3E56EDF1-8346-4982-B982-107D55F10C32}"/>
               </a:ext>
             </a:extLst>
           </p:cNvPr>
@@ -8417,7 +8417,7 @@
           <p:cNvPr id="5" name="">
             <a:extLst xmlns:a="http://schemas.openxmlformats.org/drawingml/2006/main">
               <a:ext uri="{FF2B5EF4-FFF2-40B4-BE49-F238E27FC236}">
-                <a16:creationId xmlns:a16="http://schemas.microsoft.com/office/drawing/2014/main" id="{60AE42DD-05E0-421B-8ED4-26E1529A5DEC}"/>
+                <a16:creationId xmlns:a16="http://schemas.microsoft.com/office/drawing/2014/main" id="{2272642F-D60B-490F-B4B5-C586B2709FB7}"/>
               </a:ext>
             </a:extLst>
           </p:cNvPr>
@@ -8467,7 +8467,7 @@
           <p:cNvPr id="6" name="">
             <a:extLst xmlns:a="http://schemas.openxmlformats.org/drawingml/2006/main">
               <a:ext uri="{FF2B5EF4-FFF2-40B4-BE49-F238E27FC236}">
-                <a16:creationId xmlns:a16="http://schemas.microsoft.com/office/drawing/2014/main" id="{3BFDD6FC-C05C-46E5-89F8-EEC920A56D5D}"/>
+                <a16:creationId xmlns:a16="http://schemas.microsoft.com/office/drawing/2014/main" id="{6630974A-B86F-4AEB-90F0-7890576CA851}"/>
               </a:ext>
             </a:extLst>
           </p:cNvPr>
@@ -8517,7 +8517,7 @@
           <p:cNvPr id="7" name="">
             <a:extLst xmlns:a="http://schemas.openxmlformats.org/drawingml/2006/main">
               <a:ext uri="{FF2B5EF4-FFF2-40B4-BE49-F238E27FC236}">
-                <a16:creationId xmlns:a16="http://schemas.microsoft.com/office/drawing/2014/main" id="{2ED436D4-1E85-463D-A400-6537BFEBE3EF}"/>
+                <a16:creationId xmlns:a16="http://schemas.microsoft.com/office/drawing/2014/main" id="{D2EA599D-8740-4B39-B76A-8E339EF3C197}"/>
               </a:ext>
             </a:extLst>
           </p:cNvPr>
@@ -8552,7 +8552,7 @@
           <p:cNvPr id="8" name="">
             <a:extLst xmlns:a="http://schemas.openxmlformats.org/drawingml/2006/main">
               <a:ext uri="{FF2B5EF4-FFF2-40B4-BE49-F238E27FC236}">
-                <a16:creationId xmlns:a16="http://schemas.microsoft.com/office/drawing/2014/main" id="{27047A39-E836-4997-AC22-82D0E8FD3660}"/>
+                <a16:creationId xmlns:a16="http://schemas.microsoft.com/office/drawing/2014/main" id="{BEC266B5-FBEC-45E9-A9C0-FA0FF31F1DA0}"/>
               </a:ext>
             </a:extLst>
           </p:cNvPr>
@@ -8602,7 +8602,7 @@
           <p:cNvPr id="9" name="">
             <a:extLst xmlns:a="http://schemas.openxmlformats.org/drawingml/2006/main">
               <a:ext uri="{FF2B5EF4-FFF2-40B4-BE49-F238E27FC236}">
-                <a16:creationId xmlns:a16="http://schemas.microsoft.com/office/drawing/2014/main" id="{57B7517D-D097-4C4E-AAB5-CFC6649074DA}"/>
+                <a16:creationId xmlns:a16="http://schemas.microsoft.com/office/drawing/2014/main" id="{8776BA3C-CAA8-4C25-A9FF-AF5CBD374D0C}"/>
               </a:ext>
             </a:extLst>
           </p:cNvPr>
@@ -8652,7 +8652,7 @@
           <p:cNvPr id="10" name="">
             <a:extLst xmlns:a="http://schemas.openxmlformats.org/drawingml/2006/main">
               <a:ext uri="{FF2B5EF4-FFF2-40B4-BE49-F238E27FC236}">
-                <a16:creationId xmlns:a16="http://schemas.microsoft.com/office/drawing/2014/main" id="{66226149-9911-4533-BF24-EDF91AA83A24}"/>
+                <a16:creationId xmlns:a16="http://schemas.microsoft.com/office/drawing/2014/main" id="{1E1C8425-58AD-4C43-A581-00FB038DDA67}"/>
               </a:ext>
             </a:extLst>
           </p:cNvPr>
@@ -8687,7 +8687,7 @@
           <p:cNvPr id="11" name="">
             <a:extLst xmlns:a="http://schemas.openxmlformats.org/drawingml/2006/main">
               <a:ext uri="{FF2B5EF4-FFF2-40B4-BE49-F238E27FC236}">
-                <a16:creationId xmlns:a16="http://schemas.microsoft.com/office/drawing/2014/main" id="{F0564585-5F34-42CD-B63D-1B1E8739B267}"/>
+                <a16:creationId xmlns:a16="http://schemas.microsoft.com/office/drawing/2014/main" id="{640E1C30-62A1-42D1-B27C-DC61BC50829D}"/>
               </a:ext>
             </a:extLst>
           </p:cNvPr>
@@ -8737,7 +8737,7 @@
           <p:cNvPr id="12" name="">
             <a:extLst xmlns:a="http://schemas.openxmlformats.org/drawingml/2006/main">
               <a:ext uri="{FF2B5EF4-FFF2-40B4-BE49-F238E27FC236}">
-                <a16:creationId xmlns:a16="http://schemas.microsoft.com/office/drawing/2014/main" id="{5AEFD2B0-9CE9-4B55-8E0A-717A276BDDA3}"/>
+                <a16:creationId xmlns:a16="http://schemas.microsoft.com/office/drawing/2014/main" id="{8951CFF9-9AA9-45A2-B7BF-3B20C98D90A5}"/>
               </a:ext>
             </a:extLst>
           </p:cNvPr>
@@ -8787,7 +8787,7 @@
           <p:cNvPr id="13" name="">
             <a:extLst xmlns:a="http://schemas.openxmlformats.org/drawingml/2006/main">
               <a:ext uri="{FF2B5EF4-FFF2-40B4-BE49-F238E27FC236}">
-                <a16:creationId xmlns:a16="http://schemas.microsoft.com/office/drawing/2014/main" id="{8E5B1DDE-D106-4E44-9513-19C8E466FE2B}"/>
+                <a16:creationId xmlns:a16="http://schemas.microsoft.com/office/drawing/2014/main" id="{5F9E85A3-1540-4763-AFF8-AA7EACD93DA0}"/>
               </a:ext>
             </a:extLst>
           </p:cNvPr>
@@ -8822,7 +8822,7 @@
           <p:cNvPr id="14" name="">
             <a:extLst xmlns:a="http://schemas.openxmlformats.org/drawingml/2006/main">
               <a:ext uri="{FF2B5EF4-FFF2-40B4-BE49-F238E27FC236}">
-                <a16:creationId xmlns:a16="http://schemas.microsoft.com/office/drawing/2014/main" id="{E74DB9F3-3E5C-4265-9EDF-403FD1568778}"/>
+                <a16:creationId xmlns:a16="http://schemas.microsoft.com/office/drawing/2014/main" id="{1E2C6BF6-DF22-49AA-947C-FB5247DDB253}"/>
               </a:ext>
             </a:extLst>
           </p:cNvPr>
@@ -8872,7 +8872,7 @@
           <p:cNvPr id="15" name="">
             <a:extLst xmlns:a="http://schemas.openxmlformats.org/drawingml/2006/main">
               <a:ext uri="{FF2B5EF4-FFF2-40B4-BE49-F238E27FC236}">
-                <a16:creationId xmlns:a16="http://schemas.microsoft.com/office/drawing/2014/main" id="{C353BAC2-82BE-46E2-8EE2-32A9B62091CE}"/>
+                <a16:creationId xmlns:a16="http://schemas.microsoft.com/office/drawing/2014/main" id="{C9FF4E4F-4AE5-48EC-99EB-32D6681750F9}"/>
               </a:ext>
             </a:extLst>
           </p:cNvPr>
@@ -8922,7 +8922,7 @@
           <p:cNvPr id="16" name="">
             <a:extLst xmlns:a="http://schemas.openxmlformats.org/drawingml/2006/main">
               <a:ext uri="{FF2B5EF4-FFF2-40B4-BE49-F238E27FC236}">
-                <a16:creationId xmlns:a16="http://schemas.microsoft.com/office/drawing/2014/main" id="{FBDB5797-6FBA-428B-A40E-733DE543B2B1}"/>
+                <a16:creationId xmlns:a16="http://schemas.microsoft.com/office/drawing/2014/main" id="{8048A495-BD04-4C03-A448-2E3FBC3FF73E}"/>
               </a:ext>
             </a:extLst>
           </p:cNvPr>
@@ -8953,7 +8953,7 @@
           <p:cNvPr id="17" name="">
             <a:extLst xmlns:a="http://schemas.openxmlformats.org/drawingml/2006/main">
               <a:ext uri="{FF2B5EF4-FFF2-40B4-BE49-F238E27FC236}">
-                <a16:creationId xmlns:a16="http://schemas.microsoft.com/office/drawing/2014/main" id="{F876B7D4-8EDA-42FD-93F2-6E4E5E978E6B}"/>
+                <a16:creationId xmlns:a16="http://schemas.microsoft.com/office/drawing/2014/main" id="{D8A53006-C328-42D8-9798-902717D89332}"/>
               </a:ext>
             </a:extLst>
           </p:cNvPr>
@@ -9003,7 +9003,7 @@
           <p:cNvPr id="18" name="">
             <a:extLst xmlns:a="http://schemas.openxmlformats.org/drawingml/2006/main">
               <a:ext uri="{FF2B5EF4-FFF2-40B4-BE49-F238E27FC236}">
-                <a16:creationId xmlns:a16="http://schemas.microsoft.com/office/drawing/2014/main" id="{C2020A04-C137-4BC1-9BB3-899310BB1055}"/>
+                <a16:creationId xmlns:a16="http://schemas.microsoft.com/office/drawing/2014/main" id="{062DC33C-822D-4B35-A5BE-4C62FDB376C1}"/>
               </a:ext>
             </a:extLst>
           </p:cNvPr>
@@ -9034,7 +9034,7 @@
           <p:cNvPr id="19" name="">
             <a:extLst xmlns:a="http://schemas.openxmlformats.org/drawingml/2006/main">
               <a:ext uri="{FF2B5EF4-FFF2-40B4-BE49-F238E27FC236}">
-                <a16:creationId xmlns:a16="http://schemas.microsoft.com/office/drawing/2014/main" id="{B8AC1E8C-8475-4104-8C7C-FEA6A82FD8E4}"/>
+                <a16:creationId xmlns:a16="http://schemas.microsoft.com/office/drawing/2014/main" id="{4091E40F-FFE9-492D-BA43-0CEFDBD7EEB0}"/>
               </a:ext>
             </a:extLst>
           </p:cNvPr>
@@ -9084,7 +9084,7 @@
           <p:cNvPr id="20" name="">
             <a:extLst xmlns:a="http://schemas.openxmlformats.org/drawingml/2006/main">
               <a:ext uri="{FF2B5EF4-FFF2-40B4-BE49-F238E27FC236}">
-                <a16:creationId xmlns:a16="http://schemas.microsoft.com/office/drawing/2014/main" id="{C7EA6746-4DF4-48DC-B9E1-51E0EAF9BBDE}"/>
+                <a16:creationId xmlns:a16="http://schemas.microsoft.com/office/drawing/2014/main" id="{F7D0B88A-6991-4319-AB82-28F674CA88CC}"/>
               </a:ext>
             </a:extLst>
           </p:cNvPr>
@@ -9115,7 +9115,7 @@
           <p:cNvPr id="21" name="">
             <a:extLst xmlns:a="http://schemas.openxmlformats.org/drawingml/2006/main">
               <a:ext uri="{FF2B5EF4-FFF2-40B4-BE49-F238E27FC236}">
-                <a16:creationId xmlns:a16="http://schemas.microsoft.com/office/drawing/2014/main" id="{CAEC2D96-2CAC-4440-9446-2A58AD05EAED}"/>
+                <a16:creationId xmlns:a16="http://schemas.microsoft.com/office/drawing/2014/main" id="{1BE9F7C9-58D4-4BE9-985D-F6885F9E3C19}"/>
               </a:ext>
             </a:extLst>
           </p:cNvPr>
@@ -9163,7 +9163,7 @@
     </p:spTree>
     <p:extLst>
       <p:ext uri="{BB962C8B-B14F-4D97-AF65-F5344CB8AC3E}">
-        <p14:creationId xmlns:p14="http://schemas.microsoft.com/office/powerpoint/2010/main" val="407097746"/>
+        <p14:creationId xmlns:p14="http://schemas.microsoft.com/office/powerpoint/2010/main" val="1792903742"/>
       </p:ext>
     </p:extLst>
   </p:cSld>
@@ -9194,7 +9194,7 @@
           <p:cNvPr id="1" name="">
             <a:extLst xmlns:a="http://schemas.openxmlformats.org/drawingml/2006/main">
               <a:ext uri="{FF2B5EF4-FFF2-40B4-BE49-F238E27FC236}">
-                <a16:creationId xmlns:a16="http://schemas.microsoft.com/office/drawing/2014/main" id="{8937B37F-C451-4F31-AA68-0B28804579D2}"/>
+                <a16:creationId xmlns:a16="http://schemas.microsoft.com/office/drawing/2014/main" id="{D44DA2CF-8DA0-4EF1-811E-F49127CCCBA6}"/>
               </a:ext>
             </a:extLst>
           </p:cNvPr>
@@ -9225,7 +9225,7 @@
           <p:cNvPr id="2" name="">
             <a:extLst xmlns:a="http://schemas.openxmlformats.org/drawingml/2006/main">
               <a:ext uri="{FF2B5EF4-FFF2-40B4-BE49-F238E27FC236}">
-                <a16:creationId xmlns:a16="http://schemas.microsoft.com/office/drawing/2014/main" id="{648F944D-A0AF-4579-9C1D-F5D876B5907E}"/>
+                <a16:creationId xmlns:a16="http://schemas.microsoft.com/office/drawing/2014/main" id="{FDCE40B6-1A99-4206-AA14-A0640C234CBC}"/>
               </a:ext>
             </a:extLst>
           </p:cNvPr>
@@ -9275,7 +9275,7 @@
           <p:cNvPr id="3" name="">
             <a:extLst xmlns:a="http://schemas.openxmlformats.org/drawingml/2006/main">
               <a:ext uri="{FF2B5EF4-FFF2-40B4-BE49-F238E27FC236}">
-                <a16:creationId xmlns:a16="http://schemas.microsoft.com/office/drawing/2014/main" id="{03E8050F-6BBD-4180-9A11-1745FF9BF709}"/>
+                <a16:creationId xmlns:a16="http://schemas.microsoft.com/office/drawing/2014/main" id="{0F238086-94F4-4DEA-B3F1-4BE35599E671}"/>
               </a:ext>
             </a:extLst>
           </p:cNvPr>
@@ -9325,7 +9325,7 @@
           <p:cNvPr id="4" name="">
             <a:extLst xmlns:a="http://schemas.openxmlformats.org/drawingml/2006/main">
               <a:ext uri="{FF2B5EF4-FFF2-40B4-BE49-F238E27FC236}">
-                <a16:creationId xmlns:a16="http://schemas.microsoft.com/office/drawing/2014/main" id="{B0C52DD9-6E05-43C4-8072-3A54157DB3A7}"/>
+                <a16:creationId xmlns:a16="http://schemas.microsoft.com/office/drawing/2014/main" id="{944B9438-38C3-4A7B-BFEF-DB5D8A411405}"/>
               </a:ext>
             </a:extLst>
           </p:cNvPr>
@@ -9356,7 +9356,7 @@
           <p:cNvPr id="5" name="">
             <a:extLst xmlns:a="http://schemas.openxmlformats.org/drawingml/2006/main">
               <a:ext uri="{FF2B5EF4-FFF2-40B4-BE49-F238E27FC236}">
-                <a16:creationId xmlns:a16="http://schemas.microsoft.com/office/drawing/2014/main" id="{B9531586-11CF-4BD6-82F9-797737BF3E84}"/>
+                <a16:creationId xmlns:a16="http://schemas.microsoft.com/office/drawing/2014/main" id="{5E1239BF-C856-40AB-B15D-26CC1EA1BB75}"/>
               </a:ext>
             </a:extLst>
           </p:cNvPr>
@@ -9396,7 +9396,7 @@
                   <a:srgbClr val="F5F7FB"/>
                 </a:solidFill>
               </a:rPr>
-              <a:t>Feature masking: mise à zéro d'une proportion d'entrées actives.</a:t>
+              <a:t>Masquage aléatoire d’une proportion de caractéristiques actives non nulles.</a:t>
             </a:r>
           </a:p>
         </p:txBody>
@@ -9406,7 +9406,7 @@
           <p:cNvPr id="6" name="">
             <a:extLst xmlns:a="http://schemas.openxmlformats.org/drawingml/2006/main">
               <a:ext uri="{FF2B5EF4-FFF2-40B4-BE49-F238E27FC236}">
-                <a16:creationId xmlns:a16="http://schemas.microsoft.com/office/drawing/2014/main" id="{59A2D87F-D787-467A-B41D-2C30BE2C974B}"/>
+                <a16:creationId xmlns:a16="http://schemas.microsoft.com/office/drawing/2014/main" id="{6B0AF827-CD81-4DC6-B687-BE4AF6ACA699}"/>
               </a:ext>
             </a:extLst>
           </p:cNvPr>
@@ -9437,7 +9437,7 @@
           <p:cNvPr id="7" name="">
             <a:extLst xmlns:a="http://schemas.openxmlformats.org/drawingml/2006/main">
               <a:ext uri="{FF2B5EF4-FFF2-40B4-BE49-F238E27FC236}">
-                <a16:creationId xmlns:a16="http://schemas.microsoft.com/office/drawing/2014/main" id="{24222C9A-5A0E-40AB-ADE1-B5FD7C400017}"/>
+                <a16:creationId xmlns:a16="http://schemas.microsoft.com/office/drawing/2014/main" id="{29525177-9CCF-4850-BD52-754EA6E1344A}"/>
               </a:ext>
             </a:extLst>
           </p:cNvPr>
@@ -9487,7 +9487,7 @@
           <p:cNvPr id="8" name="">
             <a:extLst xmlns:a="http://schemas.openxmlformats.org/drawingml/2006/main">
               <a:ext uri="{FF2B5EF4-FFF2-40B4-BE49-F238E27FC236}">
-                <a16:creationId xmlns:a16="http://schemas.microsoft.com/office/drawing/2014/main" id="{40E35CA9-695C-45D3-B939-81E7E95EF184}"/>
+                <a16:creationId xmlns:a16="http://schemas.microsoft.com/office/drawing/2014/main" id="{4E513D87-6E32-4A5D-8E05-F70A66B86714}"/>
               </a:ext>
             </a:extLst>
           </p:cNvPr>
@@ -9518,7 +9518,7 @@
           <p:cNvPr id="9" name="">
             <a:extLst xmlns:a="http://schemas.openxmlformats.org/drawingml/2006/main">
               <a:ext uri="{FF2B5EF4-FFF2-40B4-BE49-F238E27FC236}">
-                <a16:creationId xmlns:a16="http://schemas.microsoft.com/office/drawing/2014/main" id="{9EFEF1BB-80E8-4578-8A28-9520CF2EBC9F}"/>
+                <a16:creationId xmlns:a16="http://schemas.microsoft.com/office/drawing/2014/main" id="{D73DC6D4-4A68-430F-8FEE-C40B1FA43992}"/>
               </a:ext>
             </a:extLst>
           </p:cNvPr>
@@ -9566,7 +9566,7 @@
     </p:spTree>
     <p:extLst>
       <p:ext uri="{BB962C8B-B14F-4D97-AF65-F5344CB8AC3E}">
-        <p14:creationId xmlns:p14="http://schemas.microsoft.com/office/powerpoint/2010/main" val="1407101368"/>
+        <p14:creationId xmlns:p14="http://schemas.microsoft.com/office/powerpoint/2010/main" val="1161200986"/>
       </p:ext>
     </p:extLst>
   </p:cSld>
@@ -9597,7 +9597,7 @@
           <p:cNvPr id="1" name="">
             <a:extLst xmlns:a="http://schemas.openxmlformats.org/drawingml/2006/main">
               <a:ext uri="{FF2B5EF4-FFF2-40B4-BE49-F238E27FC236}">
-                <a16:creationId xmlns:a16="http://schemas.microsoft.com/office/drawing/2014/main" id="{613446A0-FAB6-481E-B1F8-793EECE68AFE}"/>
+                <a16:creationId xmlns:a16="http://schemas.microsoft.com/office/drawing/2014/main" id="{728C0C4F-D709-46FA-AE2D-6D2C87D9D0D4}"/>
               </a:ext>
             </a:extLst>
           </p:cNvPr>
@@ -9628,7 +9628,7 @@
           <p:cNvPr id="2" name="">
             <a:extLst xmlns:a="http://schemas.openxmlformats.org/drawingml/2006/main">
               <a:ext uri="{FF2B5EF4-FFF2-40B4-BE49-F238E27FC236}">
-                <a16:creationId xmlns:a16="http://schemas.microsoft.com/office/drawing/2014/main" id="{34A05736-784E-4C7E-B5C2-28C23943AF35}"/>
+                <a16:creationId xmlns:a16="http://schemas.microsoft.com/office/drawing/2014/main" id="{7C9DFABF-EFE1-4EE5-8990-F4558DF7F9A4}"/>
               </a:ext>
             </a:extLst>
           </p:cNvPr>
@@ -9678,7 +9678,7 @@
           <p:cNvPr id="3" name="">
             <a:extLst xmlns:a="http://schemas.openxmlformats.org/drawingml/2006/main">
               <a:ext uri="{FF2B5EF4-FFF2-40B4-BE49-F238E27FC236}">
-                <a16:creationId xmlns:a16="http://schemas.microsoft.com/office/drawing/2014/main" id="{2DC4BD3C-2317-41C1-BD56-9885E71C5B4A}"/>
+                <a16:creationId xmlns:a16="http://schemas.microsoft.com/office/drawing/2014/main" id="{32D63A3E-8DA0-4C6F-8CB7-AAF1876AE652}"/>
               </a:ext>
             </a:extLst>
           </p:cNvPr>
@@ -9728,7 +9728,7 @@
           <p:cNvPr id="4" name="">
             <a:extLst xmlns:a="http://schemas.openxmlformats.org/drawingml/2006/main">
               <a:ext uri="{FF2B5EF4-FFF2-40B4-BE49-F238E27FC236}">
-                <a16:creationId xmlns:a16="http://schemas.microsoft.com/office/drawing/2014/main" id="{D01F11AA-D4E9-4D40-B5BA-8347C2C687AB}"/>
+                <a16:creationId xmlns:a16="http://schemas.microsoft.com/office/drawing/2014/main" id="{128A68F6-CE1C-44C6-9698-3ED259703CA0}"/>
               </a:ext>
             </a:extLst>
           </p:cNvPr>
@@ -9759,7 +9759,7 @@
           <p:cNvPr id="5" name="">
             <a:extLst xmlns:a="http://schemas.openxmlformats.org/drawingml/2006/main">
               <a:ext uri="{FF2B5EF4-FFF2-40B4-BE49-F238E27FC236}">
-                <a16:creationId xmlns:a16="http://schemas.microsoft.com/office/drawing/2014/main" id="{947D9829-7F65-47E1-BB66-09900B212D97}"/>
+                <a16:creationId xmlns:a16="http://schemas.microsoft.com/office/drawing/2014/main" id="{FDA6C004-B23F-455B-BB77-7EA7F71F97D9}"/>
               </a:ext>
             </a:extLst>
           </p:cNvPr>
@@ -9809,7 +9809,7 @@
           <p:cNvPr id="6" name="">
             <a:extLst xmlns:a="http://schemas.openxmlformats.org/drawingml/2006/main">
               <a:ext uri="{FF2B5EF4-FFF2-40B4-BE49-F238E27FC236}">
-                <a16:creationId xmlns:a16="http://schemas.microsoft.com/office/drawing/2014/main" id="{95691D79-97AE-46D7-8AD6-894C4C89D270}"/>
+                <a16:creationId xmlns:a16="http://schemas.microsoft.com/office/drawing/2014/main" id="{18723256-98D2-42E6-BFDD-6C952D11D45E}"/>
               </a:ext>
             </a:extLst>
           </p:cNvPr>
@@ -9840,7 +9840,7 @@
           <p:cNvPr id="7" name="">
             <a:extLst xmlns:a="http://schemas.openxmlformats.org/drawingml/2006/main">
               <a:ext uri="{FF2B5EF4-FFF2-40B4-BE49-F238E27FC236}">
-                <a16:creationId xmlns:a16="http://schemas.microsoft.com/office/drawing/2014/main" id="{C1311805-6774-4789-BD06-FFE568A40A80}"/>
+                <a16:creationId xmlns:a16="http://schemas.microsoft.com/office/drawing/2014/main" id="{5AFB6C8E-17B4-4E5C-B78C-71DF957A2925}"/>
               </a:ext>
             </a:extLst>
           </p:cNvPr>
@@ -9890,7 +9890,7 @@
           <p:cNvPr id="8" name="">
             <a:extLst xmlns:a="http://schemas.openxmlformats.org/drawingml/2006/main">
               <a:ext uri="{FF2B5EF4-FFF2-40B4-BE49-F238E27FC236}">
-                <a16:creationId xmlns:a16="http://schemas.microsoft.com/office/drawing/2014/main" id="{1A322D54-D488-40F0-AC6E-BB9C4B8CE150}"/>
+                <a16:creationId xmlns:a16="http://schemas.microsoft.com/office/drawing/2014/main" id="{421EBB02-A5F1-4307-8ECC-D31131840B33}"/>
               </a:ext>
             </a:extLst>
           </p:cNvPr>
@@ -9921,7 +9921,7 @@
           <p:cNvPr id="9" name="">
             <a:extLst xmlns:a="http://schemas.openxmlformats.org/drawingml/2006/main">
               <a:ext uri="{FF2B5EF4-FFF2-40B4-BE49-F238E27FC236}">
-                <a16:creationId xmlns:a16="http://schemas.microsoft.com/office/drawing/2014/main" id="{ADDAE16C-5630-4F5E-90DC-B9C94908995A}"/>
+                <a16:creationId xmlns:a16="http://schemas.microsoft.com/office/drawing/2014/main" id="{48FA92BB-5463-4ADC-9755-2E95B759E60D}"/>
               </a:ext>
             </a:extLst>
           </p:cNvPr>
@@ -9971,7 +9971,7 @@
           <p:cNvPr id="10" name="">
             <a:extLst xmlns:a="http://schemas.openxmlformats.org/drawingml/2006/main">
               <a:ext uri="{FF2B5EF4-FFF2-40B4-BE49-F238E27FC236}">
-                <a16:creationId xmlns:a16="http://schemas.microsoft.com/office/drawing/2014/main" id="{9D0F21B7-B720-4112-ADF3-3974F62BB0FE}"/>
+                <a16:creationId xmlns:a16="http://schemas.microsoft.com/office/drawing/2014/main" id="{55532141-3C67-4472-8782-F3E92988B2AF}"/>
               </a:ext>
             </a:extLst>
           </p:cNvPr>
@@ -10002,7 +10002,7 @@
           <p:cNvPr id="11" name="">
             <a:extLst xmlns:a="http://schemas.openxmlformats.org/drawingml/2006/main">
               <a:ext uri="{FF2B5EF4-FFF2-40B4-BE49-F238E27FC236}">
-                <a16:creationId xmlns:a16="http://schemas.microsoft.com/office/drawing/2014/main" id="{D65B692F-4D61-4625-B88F-92A3F9089804}"/>
+                <a16:creationId xmlns:a16="http://schemas.microsoft.com/office/drawing/2014/main" id="{672297D4-FA8F-4F20-9B62-58BC94A30CC1}"/>
               </a:ext>
             </a:extLst>
           </p:cNvPr>
@@ -10050,7 +10050,7 @@
     </p:spTree>
     <p:extLst>
       <p:ext uri="{BB962C8B-B14F-4D97-AF65-F5344CB8AC3E}">
-        <p14:creationId xmlns:p14="http://schemas.microsoft.com/office/powerpoint/2010/main" val="776215755"/>
+        <p14:creationId xmlns:p14="http://schemas.microsoft.com/office/powerpoint/2010/main" val="1167384020"/>
       </p:ext>
     </p:extLst>
   </p:cSld>
@@ -10081,7 +10081,7 @@
           <p:cNvPr id="1" name="">
             <a:extLst xmlns:a="http://schemas.openxmlformats.org/drawingml/2006/main">
               <a:ext uri="{FF2B5EF4-FFF2-40B4-BE49-F238E27FC236}">
-                <a16:creationId xmlns:a16="http://schemas.microsoft.com/office/drawing/2014/main" id="{3DE1151C-FA19-454E-88CF-1E07E971BDFF}"/>
+                <a16:creationId xmlns:a16="http://schemas.microsoft.com/office/drawing/2014/main" id="{7EC4D4B7-62C3-4938-8B3F-2C6E8F69FBB8}"/>
               </a:ext>
             </a:extLst>
           </p:cNvPr>
@@ -10112,7 +10112,7 @@
           <p:cNvPr id="2" name="">
             <a:extLst xmlns:a="http://schemas.openxmlformats.org/drawingml/2006/main">
               <a:ext uri="{FF2B5EF4-FFF2-40B4-BE49-F238E27FC236}">
-                <a16:creationId xmlns:a16="http://schemas.microsoft.com/office/drawing/2014/main" id="{4240D270-D466-4A59-9921-9E17014D9954}"/>
+                <a16:creationId xmlns:a16="http://schemas.microsoft.com/office/drawing/2014/main" id="{A100750B-A11F-40FD-B058-17540C161ED2}"/>
               </a:ext>
             </a:extLst>
           </p:cNvPr>
@@ -10162,7 +10162,7 @@
           <p:cNvPr id="3" name="">
             <a:extLst xmlns:a="http://schemas.openxmlformats.org/drawingml/2006/main">
               <a:ext uri="{FF2B5EF4-FFF2-40B4-BE49-F238E27FC236}">
-                <a16:creationId xmlns:a16="http://schemas.microsoft.com/office/drawing/2014/main" id="{F91A71F1-2DC8-44E8-9A1E-54F2F749F54D}"/>
+                <a16:creationId xmlns:a16="http://schemas.microsoft.com/office/drawing/2014/main" id="{D333ACC6-99E4-4B28-A3AE-E3260223385E}"/>
               </a:ext>
             </a:extLst>
           </p:cNvPr>
@@ -10219,7 +10219,7 @@
         </p:xfrm>
         <a:graphic xmlns:a="http://schemas.openxmlformats.org/drawingml/2006/main">
           <a:graphicData uri="http://schemas.openxmlformats.org/drawingml/2006/chart">
-            <c:chart xmlns:r="http://schemas.openxmlformats.org/officeDocument/2006/relationships" xmlns:c="http://schemas.openxmlformats.org/drawingml/2006/chart" r:id="R2c270ddae6d44e51"/>
+            <c:chart xmlns:r="http://schemas.openxmlformats.org/officeDocument/2006/relationships" xmlns:c="http://schemas.openxmlformats.org/drawingml/2006/chart" r:id="Ra6de84d631c6436a"/>
           </a:graphicData>
         </a:graphic>
       </p:graphicFrame>
@@ -10228,7 +10228,7 @@
           <p:cNvPr id="5" name="">
             <a:extLst xmlns:a="http://schemas.openxmlformats.org/drawingml/2006/main">
               <a:ext uri="{FF2B5EF4-FFF2-40B4-BE49-F238E27FC236}">
-                <a16:creationId xmlns:a16="http://schemas.microsoft.com/office/drawing/2014/main" id="{BC1552E2-DCCD-4B43-8886-2FAAE2686688}"/>
+                <a16:creationId xmlns:a16="http://schemas.microsoft.com/office/drawing/2014/main" id="{29E3C6A1-1695-477F-867B-C5C6EA5A33B1}"/>
               </a:ext>
             </a:extLst>
           </p:cNvPr>
@@ -10278,7 +10278,7 @@
           <p:cNvPr id="6" name="">
             <a:extLst xmlns:a="http://schemas.openxmlformats.org/drawingml/2006/main">
               <a:ext uri="{FF2B5EF4-FFF2-40B4-BE49-F238E27FC236}">
-                <a16:creationId xmlns:a16="http://schemas.microsoft.com/office/drawing/2014/main" id="{6D8C6466-BBD8-4F6B-AF5F-18E771927827}"/>
+                <a16:creationId xmlns:a16="http://schemas.microsoft.com/office/drawing/2014/main" id="{B0CEF0C9-3F07-4033-BEBD-43307C34DBCC}"/>
               </a:ext>
             </a:extLst>
           </p:cNvPr>
@@ -10326,7 +10326,7 @@
     </p:spTree>
     <p:extLst>
       <p:ext uri="{BB962C8B-B14F-4D97-AF65-F5344CB8AC3E}">
-        <p14:creationId xmlns:p14="http://schemas.microsoft.com/office/powerpoint/2010/main" val="192948972"/>
+        <p14:creationId xmlns:p14="http://schemas.microsoft.com/office/powerpoint/2010/main" val="745437529"/>
       </p:ext>
     </p:extLst>
   </p:cSld>
@@ -10357,7 +10357,7 @@
           <p:cNvPr id="1" name="">
             <a:extLst xmlns:a="http://schemas.openxmlformats.org/drawingml/2006/main">
               <a:ext uri="{FF2B5EF4-FFF2-40B4-BE49-F238E27FC236}">
-                <a16:creationId xmlns:a16="http://schemas.microsoft.com/office/drawing/2014/main" id="{C73806B3-EB66-4D2F-A567-A95E295C6A8E}"/>
+                <a16:creationId xmlns:a16="http://schemas.microsoft.com/office/drawing/2014/main" id="{11D0B655-F505-4C73-BF0A-7BE7E23EFB37}"/>
               </a:ext>
             </a:extLst>
           </p:cNvPr>
@@ -10388,7 +10388,7 @@
           <p:cNvPr id="2" name="">
             <a:extLst xmlns:a="http://schemas.openxmlformats.org/drawingml/2006/main">
               <a:ext uri="{FF2B5EF4-FFF2-40B4-BE49-F238E27FC236}">
-                <a16:creationId xmlns:a16="http://schemas.microsoft.com/office/drawing/2014/main" id="{4A517D70-59D9-4FE3-9D28-8C52F3AD1B7A}"/>
+                <a16:creationId xmlns:a16="http://schemas.microsoft.com/office/drawing/2014/main" id="{6C3C8FB3-0584-4B50-9814-510D3D06AD62}"/>
               </a:ext>
             </a:extLst>
           </p:cNvPr>
@@ -10438,7 +10438,7 @@
           <p:cNvPr id="3" name="">
             <a:extLst xmlns:a="http://schemas.openxmlformats.org/drawingml/2006/main">
               <a:ext uri="{FF2B5EF4-FFF2-40B4-BE49-F238E27FC236}">
-                <a16:creationId xmlns:a16="http://schemas.microsoft.com/office/drawing/2014/main" id="{34945F85-AF57-4ED8-A727-75F95DA041DA}"/>
+                <a16:creationId xmlns:a16="http://schemas.microsoft.com/office/drawing/2014/main" id="{75F553D7-3064-4ABA-8211-A4B51F88E694}"/>
               </a:ext>
             </a:extLst>
           </p:cNvPr>
@@ -10495,7 +10495,7 @@
         </p:xfrm>
         <a:graphic xmlns:a="http://schemas.openxmlformats.org/drawingml/2006/main">
           <a:graphicData uri="http://schemas.openxmlformats.org/drawingml/2006/chart">
-            <c:chart xmlns:r="http://schemas.openxmlformats.org/officeDocument/2006/relationships" xmlns:c="http://schemas.openxmlformats.org/drawingml/2006/chart" r:id="Rd61e245d9c6a4941"/>
+            <c:chart xmlns:r="http://schemas.openxmlformats.org/officeDocument/2006/relationships" xmlns:c="http://schemas.openxmlformats.org/drawingml/2006/chart" r:id="R7be0bcb673e9486b"/>
           </a:graphicData>
         </a:graphic>
       </p:graphicFrame>
@@ -10504,7 +10504,7 @@
           <p:cNvPr id="5" name="">
             <a:extLst xmlns:a="http://schemas.openxmlformats.org/drawingml/2006/main">
               <a:ext uri="{FF2B5EF4-FFF2-40B4-BE49-F238E27FC236}">
-                <a16:creationId xmlns:a16="http://schemas.microsoft.com/office/drawing/2014/main" id="{4CBBCAA8-2E8F-4D5E-8845-3370A93D008C}"/>
+                <a16:creationId xmlns:a16="http://schemas.microsoft.com/office/drawing/2014/main" id="{0F3225AB-DB69-48CE-8521-F9467DAD4A18}"/>
               </a:ext>
             </a:extLst>
           </p:cNvPr>
@@ -10552,7 +10552,7 @@
     </p:spTree>
     <p:extLst>
       <p:ext uri="{BB962C8B-B14F-4D97-AF65-F5344CB8AC3E}">
-        <p14:creationId xmlns:p14="http://schemas.microsoft.com/office/powerpoint/2010/main" val="922898469"/>
+        <p14:creationId xmlns:p14="http://schemas.microsoft.com/office/powerpoint/2010/main" val="1177159007"/>
       </p:ext>
     </p:extLst>
   </p:cSld>

</xml_diff>